<commit_message>
Sesion 1: deck con casos de uso multi-nube (Azure y AWS), diagramas de flujo e imagenes
Anade lamina de equivalencias FinOps Azure <-> AWS y dos casos de uso con diagrama
de flujo e imagen: el recurso olvidado (zombie) y la sorpresa del egress. 17 laminas.
</commit_message>
<xml_diff>
--- a/01-fundamentos-finops/diapositivas/88-EAN_S01_Teoria_Fundamentos-FinOps.pptx
+++ b/01-fundamentos-finops/diapositivas/88-EAN_S01_Teoria_Fundamentos-FinOps.pptx
@@ -19,6 +19,9 @@
     <p:sldId id="267" r:id="rId18"/>
     <p:sldId id="268" r:id="rId19"/>
     <p:sldId id="269" r:id="rId20"/>
+    <p:sldId id="270" r:id="rId21"/>
+    <p:sldId id="271" r:id="rId22"/>
+    <p:sldId id="272" r:id="rId23"/>
   </p:sldIdLst>
   <p:sldSz cx="12191695" cy="6858000" type="screen4x3"/>
   <p:notesSz cx="6858000" cy="9144000"/>
@@ -4992,7 +4995,7 @@
                 </a:solidFill>
                 <a:latin typeface="Calibri"/>
               </a:rPr>
-              <a:t>La regla de oro de la Sesión 1</a:t>
+              <a:t>FinOps es multi-nube: mismos principios, otra consola</a:t>
             </a:r>
           </a:p>
         </p:txBody>
@@ -5034,29 +5037,153 @@
                 </a:solidFill>
                 <a:latin typeface="Calibri"/>
               </a:rPr>
-              <a:t>Con la que arranca todo el resto del curso</a:t>
-            </a:r>
-          </a:p>
-        </p:txBody>
-      </p:sp>
-      <p:sp>
-        <p:nvSpPr>
-          <p:cNvPr id="4" name="Rounded Rectangle 3"/>
+              <a:t>Aprendes en Azure, pero el marco aplica igual en AWS (y GCP)</a:t>
+            </a:r>
+          </a:p>
+        </p:txBody>
+      </p:sp>
+      <p:sp>
+        <p:nvSpPr>
+          <p:cNvPr id="4" name="TextBox 3"/>
+          <p:cNvSpPr txBox="1"/>
+          <p:nvPr/>
+        </p:nvSpPr>
+        <p:spPr>
+          <a:xfrm>
+            <a:off x="868680" y="1737360"/>
+            <a:ext cx="3749039" cy="274320"/>
+          </a:xfrm>
+          <a:prstGeom prst="rect">
+            <a:avLst/>
+          </a:prstGeom>
+          <a:noFill/>
+        </p:spPr>
+        <p:txBody>
+          <a:bodyPr wrap="square">
+            <a:spAutoFit/>
+          </a:bodyPr>
+          <a:lstStyle/>
+          <a:p>
+            <a:pPr algn="l">
+              <a:spcBef>
+                <a:spcPts val="0"/>
+              </a:spcBef>
+              <a:spcAft>
+                <a:spcPts val="400"/>
+              </a:spcAft>
+            </a:pPr>
+            <a:r>
+              <a:rPr sz="1100" b="1" i="0">
+                <a:solidFill>
+                  <a:srgbClr val="595959"/>
+                </a:solidFill>
+                <a:latin typeface="Calibri"/>
+              </a:rPr>
+              <a:t>NECESIDAD FinOps</a:t>
+            </a:r>
+          </a:p>
+        </p:txBody>
+      </p:sp>
+      <p:sp>
+        <p:nvSpPr>
+          <p:cNvPr id="5" name="TextBox 4"/>
+          <p:cNvSpPr txBox="1"/>
+          <p:nvPr/>
+        </p:nvSpPr>
+        <p:spPr>
+          <a:xfrm>
+            <a:off x="4754880" y="1737360"/>
+            <a:ext cx="3291840" cy="274320"/>
+          </a:xfrm>
+          <a:prstGeom prst="rect">
+            <a:avLst/>
+          </a:prstGeom>
+          <a:noFill/>
+        </p:spPr>
+        <p:txBody>
+          <a:bodyPr wrap="square">
+            <a:spAutoFit/>
+          </a:bodyPr>
+          <a:lstStyle/>
+          <a:p>
+            <a:pPr algn="l">
+              <a:spcBef>
+                <a:spcPts val="0"/>
+              </a:spcBef>
+              <a:spcAft>
+                <a:spcPts val="400"/>
+              </a:spcAft>
+            </a:pPr>
+            <a:r>
+              <a:rPr sz="1150" b="1" i="0">
+                <a:solidFill>
+                  <a:srgbClr val="1F4E9C"/>
+                </a:solidFill>
+                <a:latin typeface="Calibri"/>
+              </a:rPr>
+              <a:t>AZURE</a:t>
+            </a:r>
+          </a:p>
+        </p:txBody>
+      </p:sp>
+      <p:sp>
+        <p:nvSpPr>
+          <p:cNvPr id="6" name="TextBox 5"/>
+          <p:cNvSpPr txBox="1"/>
+          <p:nvPr/>
+        </p:nvSpPr>
+        <p:spPr>
+          <a:xfrm>
+            <a:off x="8229600" y="1737360"/>
+            <a:ext cx="3291840" cy="274320"/>
+          </a:xfrm>
+          <a:prstGeom prst="rect">
+            <a:avLst/>
+          </a:prstGeom>
+          <a:noFill/>
+        </p:spPr>
+        <p:txBody>
+          <a:bodyPr wrap="square">
+            <a:spAutoFit/>
+          </a:bodyPr>
+          <a:lstStyle/>
+          <a:p>
+            <a:pPr algn="l">
+              <a:spcBef>
+                <a:spcPts val="0"/>
+              </a:spcBef>
+              <a:spcAft>
+                <a:spcPts val="400"/>
+              </a:spcAft>
+            </a:pPr>
+            <a:r>
+              <a:rPr sz="1150" b="1" i="0">
+                <a:solidFill>
+                  <a:srgbClr val="8A6D1F"/>
+                </a:solidFill>
+                <a:latin typeface="Calibri"/>
+              </a:rPr>
+              <a:t>AWS</a:t>
+            </a:r>
+          </a:p>
+        </p:txBody>
+      </p:sp>
+      <p:sp>
+        <p:nvSpPr>
+          <p:cNvPr id="7" name="Rectangle 6"/>
           <p:cNvSpPr/>
           <p:nvPr/>
         </p:nvSpPr>
         <p:spPr>
           <a:xfrm>
-            <a:off x="1280160" y="2103120"/>
-            <a:ext cx="9601200" cy="1554480"/>
-          </a:xfrm>
-          <a:prstGeom prst="roundRect">
-            <a:avLst>
-              <a:gd name="adj" fmla="val 6000"/>
-            </a:avLst>
+            <a:off x="640080" y="2103120"/>
+            <a:ext cx="109728" cy="502920"/>
+          </a:xfrm>
+          <a:prstGeom prst="rect">
+            <a:avLst/>
           </a:prstGeom>
           <a:solidFill>
-            <a:srgbClr val="1F3864"/>
+            <a:srgbClr val="1E7C3C"/>
           </a:solidFill>
           <a:ln>
             <a:noFill/>
@@ -5078,39 +5205,23 @@
           </a:fontRef>
         </p:style>
         <p:txBody>
-          <a:bodyPr rtlCol="0" anchor="ctr" lIns="548640" rIns="457200" wrap="square"/>
-          <a:lstStyle/>
-          <a:p>
-            <a:pPr algn="l">
-              <a:spcBef>
-                <a:spcPts val="0"/>
-              </a:spcBef>
-              <a:spcAft>
-                <a:spcPts val="400"/>
-              </a:spcAft>
-            </a:pPr>
-            <a:r>
-              <a:rPr sz="1800" b="1" i="1">
-                <a:solidFill>
-                  <a:srgbClr val="FFFFFF"/>
-                </a:solidFill>
-                <a:latin typeface="Calibri"/>
-              </a:rPr>
-              <a:t>«No puedes optimizar —ni gobernar, ni presupuestar— lo que no puedes ver. La visibilidad del costo es el cimiento de FinOps.»</a:t>
-            </a:r>
-          </a:p>
-        </p:txBody>
-      </p:sp>
-      <p:sp>
-        <p:nvSpPr>
-          <p:cNvPr id="5" name="TextBox 4"/>
+          <a:bodyPr rtlCol="0" anchor="ctr"/>
+          <a:lstStyle/>
+          <a:p>
+            <a:pPr algn="ctr"/>
+          </a:p>
+        </p:txBody>
+      </p:sp>
+      <p:sp>
+        <p:nvSpPr>
+          <p:cNvPr id="8" name="TextBox 7"/>
           <p:cNvSpPr txBox="1"/>
           <p:nvPr/>
         </p:nvSpPr>
         <p:spPr>
           <a:xfrm>
-            <a:off x="1280160" y="4114800"/>
-            <a:ext cx="9692640" cy="457200"/>
+            <a:off x="868680" y="2157984"/>
+            <a:ext cx="3794760" cy="411480"/>
           </a:xfrm>
           <a:prstGeom prst="rect">
             <a:avLst/>
@@ -5123,37 +5234,36 @@
           </a:bodyPr>
           <a:lstStyle/>
           <a:p>
-            <a:pPr algn="l" indent="-137160" marL="182880">
-              <a:spcBef>
-                <a:spcPts val="0"/>
-              </a:spcBef>
-              <a:spcAft>
-                <a:spcPts val="400"/>
-              </a:spcAft>
-              <a:buChar char="•"/>
-            </a:pPr>
-            <a:r>
-              <a:rPr sz="1350" b="0" i="0">
+            <a:pPr algn="l">
+              <a:spcBef>
+                <a:spcPts val="0"/>
+              </a:spcBef>
+              <a:spcAft>
+                <a:spcPts val="400"/>
+              </a:spcAft>
+            </a:pPr>
+            <a:r>
+              <a:rPr sz="1250" b="1" i="0">
                 <a:solidFill>
                   <a:srgbClr val="333333"/>
                 </a:solidFill>
                 <a:latin typeface="Calibri"/>
               </a:rPr>
-              <a:t>Por eso INFORMAR es la primera fase del framework.</a:t>
-            </a:r>
-          </a:p>
-        </p:txBody>
-      </p:sp>
-      <p:sp>
-        <p:nvSpPr>
-          <p:cNvPr id="6" name="TextBox 5"/>
+              <a:t>Ver el gasto</a:t>
+            </a:r>
+          </a:p>
+        </p:txBody>
+      </p:sp>
+      <p:sp>
+        <p:nvSpPr>
+          <p:cNvPr id="9" name="TextBox 8"/>
           <p:cNvSpPr txBox="1"/>
           <p:nvPr/>
         </p:nvSpPr>
         <p:spPr>
           <a:xfrm>
-            <a:off x="1280160" y="4681728"/>
-            <a:ext cx="9692640" cy="457200"/>
+            <a:off x="4754880" y="2157984"/>
+            <a:ext cx="3383280" cy="411480"/>
           </a:xfrm>
           <a:prstGeom prst="rect">
             <a:avLst/>
@@ -5166,37 +5276,36 @@
           </a:bodyPr>
           <a:lstStyle/>
           <a:p>
-            <a:pPr algn="l" indent="-137160" marL="182880">
-              <a:spcBef>
-                <a:spcPts val="0"/>
-              </a:spcBef>
-              <a:spcAft>
-                <a:spcPts val="400"/>
-              </a:spcAft>
-              <a:buChar char="•"/>
-            </a:pPr>
-            <a:r>
-              <a:rPr sz="1350" b="0" i="0">
+            <a:pPr algn="l">
+              <a:spcBef>
+                <a:spcPts val="0"/>
+              </a:spcBef>
+              <a:spcAft>
+                <a:spcPts val="400"/>
+              </a:spcAft>
+            </a:pPr>
+            <a:r>
+              <a:rPr sz="1150" b="0" i="0">
                 <a:solidFill>
                   <a:srgbClr val="333333"/>
                 </a:solidFill>
                 <a:latin typeface="Calibri"/>
               </a:rPr>
-              <a:t>Hoy consigues visibilidad; la S2 la hace útil con etiquetas y asignación.</a:t>
-            </a:r>
-          </a:p>
-        </p:txBody>
-      </p:sp>
-      <p:sp>
-        <p:nvSpPr>
-          <p:cNvPr id="7" name="TextBox 6"/>
+              <a:t>Cost Management · Cost Analysis</a:t>
+            </a:r>
+          </a:p>
+        </p:txBody>
+      </p:sp>
+      <p:sp>
+        <p:nvSpPr>
+          <p:cNvPr id="10" name="TextBox 9"/>
           <p:cNvSpPr txBox="1"/>
           <p:nvPr/>
         </p:nvSpPr>
         <p:spPr>
           <a:xfrm>
-            <a:off x="1280160" y="5248656"/>
-            <a:ext cx="9692640" cy="457200"/>
+            <a:off x="8229600" y="2157984"/>
+            <a:ext cx="3474720" cy="411480"/>
           </a:xfrm>
           <a:prstGeom prst="rect">
             <a:avLst/>
@@ -5209,30 +5318,921 @@
           </a:bodyPr>
           <a:lstStyle/>
           <a:p>
-            <a:pPr algn="l" indent="-137160" marL="182880">
-              <a:spcBef>
-                <a:spcPts val="0"/>
-              </a:spcBef>
-              <a:spcAft>
-                <a:spcPts val="400"/>
-              </a:spcAft>
-              <a:buChar char="•"/>
-            </a:pPr>
-            <a:r>
-              <a:rPr sz="1350" b="0" i="0">
+            <a:pPr algn="l">
+              <a:spcBef>
+                <a:spcPts val="0"/>
+              </a:spcBef>
+              <a:spcAft>
+                <a:spcPts val="400"/>
+              </a:spcAft>
+            </a:pPr>
+            <a:r>
+              <a:rPr sz="1150" b="0" i="0">
                 <a:solidFill>
                   <a:srgbClr val="333333"/>
                 </a:solidFill>
                 <a:latin typeface="Calibri"/>
               </a:rPr>
-              <a:t>Sin este cimiento, presupuestar (S3) y optimizar (S4) son adivinar.</a:t>
-            </a:r>
-          </a:p>
-        </p:txBody>
-      </p:sp>
-      <p:sp>
-        <p:nvSpPr>
-          <p:cNvPr id="8" name="TextBox 7"/>
+              <a:t>Cost Explorer</a:t>
+            </a:r>
+          </a:p>
+        </p:txBody>
+      </p:sp>
+      <p:sp>
+        <p:nvSpPr>
+          <p:cNvPr id="11" name="Rectangle 10"/>
+          <p:cNvSpPr/>
+          <p:nvPr/>
+        </p:nvSpPr>
+        <p:spPr>
+          <a:xfrm>
+            <a:off x="640080" y="2679192"/>
+            <a:ext cx="109728" cy="502920"/>
+          </a:xfrm>
+          <a:prstGeom prst="rect">
+            <a:avLst/>
+          </a:prstGeom>
+          <a:solidFill>
+            <a:srgbClr val="1E7C3C"/>
+          </a:solidFill>
+          <a:ln>
+            <a:noFill/>
+          </a:ln>
+          <a:effectLst/>
+        </p:spPr>
+        <p:style>
+          <a:lnRef idx="1">
+            <a:schemeClr val="accent1"/>
+          </a:lnRef>
+          <a:fillRef idx="3">
+            <a:schemeClr val="accent1"/>
+          </a:fillRef>
+          <a:effectRef idx="2">
+            <a:schemeClr val="accent1"/>
+          </a:effectRef>
+          <a:fontRef idx="minor">
+            <a:schemeClr val="lt1"/>
+          </a:fontRef>
+        </p:style>
+        <p:txBody>
+          <a:bodyPr rtlCol="0" anchor="ctr"/>
+          <a:lstStyle/>
+          <a:p>
+            <a:pPr algn="ctr"/>
+          </a:p>
+        </p:txBody>
+      </p:sp>
+      <p:sp>
+        <p:nvSpPr>
+          <p:cNvPr id="12" name="TextBox 11"/>
+          <p:cNvSpPr txBox="1"/>
+          <p:nvPr/>
+        </p:nvSpPr>
+        <p:spPr>
+          <a:xfrm>
+            <a:off x="868680" y="2734056"/>
+            <a:ext cx="3794760" cy="411480"/>
+          </a:xfrm>
+          <a:prstGeom prst="rect">
+            <a:avLst/>
+          </a:prstGeom>
+          <a:noFill/>
+        </p:spPr>
+        <p:txBody>
+          <a:bodyPr wrap="square">
+            <a:spAutoFit/>
+          </a:bodyPr>
+          <a:lstStyle/>
+          <a:p>
+            <a:pPr algn="l">
+              <a:spcBef>
+                <a:spcPts val="0"/>
+              </a:spcBef>
+              <a:spcAft>
+                <a:spcPts val="400"/>
+              </a:spcAft>
+            </a:pPr>
+            <a:r>
+              <a:rPr sz="1250" b="1" i="0">
+                <a:solidFill>
+                  <a:srgbClr val="333333"/>
+                </a:solidFill>
+                <a:latin typeface="Calibri"/>
+              </a:rPr>
+              <a:t>Presupuestar y alertar</a:t>
+            </a:r>
+          </a:p>
+        </p:txBody>
+      </p:sp>
+      <p:sp>
+        <p:nvSpPr>
+          <p:cNvPr id="13" name="TextBox 12"/>
+          <p:cNvSpPr txBox="1"/>
+          <p:nvPr/>
+        </p:nvSpPr>
+        <p:spPr>
+          <a:xfrm>
+            <a:off x="4754880" y="2734056"/>
+            <a:ext cx="3383280" cy="411480"/>
+          </a:xfrm>
+          <a:prstGeom prst="rect">
+            <a:avLst/>
+          </a:prstGeom>
+          <a:noFill/>
+        </p:spPr>
+        <p:txBody>
+          <a:bodyPr wrap="square">
+            <a:spAutoFit/>
+          </a:bodyPr>
+          <a:lstStyle/>
+          <a:p>
+            <a:pPr algn="l">
+              <a:spcBef>
+                <a:spcPts val="0"/>
+              </a:spcBef>
+              <a:spcAft>
+                <a:spcPts val="400"/>
+              </a:spcAft>
+            </a:pPr>
+            <a:r>
+              <a:rPr sz="1150" b="0" i="0">
+                <a:solidFill>
+                  <a:srgbClr val="333333"/>
+                </a:solidFill>
+                <a:latin typeface="Calibri"/>
+              </a:rPr>
+              <a:t>Azure Budgets</a:t>
+            </a:r>
+          </a:p>
+        </p:txBody>
+      </p:sp>
+      <p:sp>
+        <p:nvSpPr>
+          <p:cNvPr id="14" name="TextBox 13"/>
+          <p:cNvSpPr txBox="1"/>
+          <p:nvPr/>
+        </p:nvSpPr>
+        <p:spPr>
+          <a:xfrm>
+            <a:off x="8229600" y="2734056"/>
+            <a:ext cx="3474720" cy="411480"/>
+          </a:xfrm>
+          <a:prstGeom prst="rect">
+            <a:avLst/>
+          </a:prstGeom>
+          <a:noFill/>
+        </p:spPr>
+        <p:txBody>
+          <a:bodyPr wrap="square">
+            <a:spAutoFit/>
+          </a:bodyPr>
+          <a:lstStyle/>
+          <a:p>
+            <a:pPr algn="l">
+              <a:spcBef>
+                <a:spcPts val="0"/>
+              </a:spcBef>
+              <a:spcAft>
+                <a:spcPts val="400"/>
+              </a:spcAft>
+            </a:pPr>
+            <a:r>
+              <a:rPr sz="1150" b="0" i="0">
+                <a:solidFill>
+                  <a:srgbClr val="333333"/>
+                </a:solidFill>
+                <a:latin typeface="Calibri"/>
+              </a:rPr>
+              <a:t>AWS Budgets</a:t>
+            </a:r>
+          </a:p>
+        </p:txBody>
+      </p:sp>
+      <p:sp>
+        <p:nvSpPr>
+          <p:cNvPr id="15" name="Rectangle 14"/>
+          <p:cNvSpPr/>
+          <p:nvPr/>
+        </p:nvSpPr>
+        <p:spPr>
+          <a:xfrm>
+            <a:off x="640080" y="3255264"/>
+            <a:ext cx="109728" cy="502920"/>
+          </a:xfrm>
+          <a:prstGeom prst="rect">
+            <a:avLst/>
+          </a:prstGeom>
+          <a:solidFill>
+            <a:srgbClr val="1E7C3C"/>
+          </a:solidFill>
+          <a:ln>
+            <a:noFill/>
+          </a:ln>
+          <a:effectLst/>
+        </p:spPr>
+        <p:style>
+          <a:lnRef idx="1">
+            <a:schemeClr val="accent1"/>
+          </a:lnRef>
+          <a:fillRef idx="3">
+            <a:schemeClr val="accent1"/>
+          </a:fillRef>
+          <a:effectRef idx="2">
+            <a:schemeClr val="accent1"/>
+          </a:effectRef>
+          <a:fontRef idx="minor">
+            <a:schemeClr val="lt1"/>
+          </a:fontRef>
+        </p:style>
+        <p:txBody>
+          <a:bodyPr rtlCol="0" anchor="ctr"/>
+          <a:lstStyle/>
+          <a:p>
+            <a:pPr algn="ctr"/>
+          </a:p>
+        </p:txBody>
+      </p:sp>
+      <p:sp>
+        <p:nvSpPr>
+          <p:cNvPr id="16" name="TextBox 15"/>
+          <p:cNvSpPr txBox="1"/>
+          <p:nvPr/>
+        </p:nvSpPr>
+        <p:spPr>
+          <a:xfrm>
+            <a:off x="868680" y="3310128"/>
+            <a:ext cx="3794760" cy="411480"/>
+          </a:xfrm>
+          <a:prstGeom prst="rect">
+            <a:avLst/>
+          </a:prstGeom>
+          <a:noFill/>
+        </p:spPr>
+        <p:txBody>
+          <a:bodyPr wrap="square">
+            <a:spAutoFit/>
+          </a:bodyPr>
+          <a:lstStyle/>
+          <a:p>
+            <a:pPr algn="l">
+              <a:spcBef>
+                <a:spcPts val="0"/>
+              </a:spcBef>
+              <a:spcAft>
+                <a:spcPts val="400"/>
+              </a:spcAft>
+            </a:pPr>
+            <a:r>
+              <a:rPr sz="1250" b="1" i="0">
+                <a:solidFill>
+                  <a:srgbClr val="333333"/>
+                </a:solidFill>
+                <a:latin typeface="Calibri"/>
+              </a:rPr>
+              <a:t>Recomendaciones de ahorro</a:t>
+            </a:r>
+          </a:p>
+        </p:txBody>
+      </p:sp>
+      <p:sp>
+        <p:nvSpPr>
+          <p:cNvPr id="17" name="TextBox 16"/>
+          <p:cNvSpPr txBox="1"/>
+          <p:nvPr/>
+        </p:nvSpPr>
+        <p:spPr>
+          <a:xfrm>
+            <a:off x="4754880" y="3310128"/>
+            <a:ext cx="3383280" cy="411480"/>
+          </a:xfrm>
+          <a:prstGeom prst="rect">
+            <a:avLst/>
+          </a:prstGeom>
+          <a:noFill/>
+        </p:spPr>
+        <p:txBody>
+          <a:bodyPr wrap="square">
+            <a:spAutoFit/>
+          </a:bodyPr>
+          <a:lstStyle/>
+          <a:p>
+            <a:pPr algn="l">
+              <a:spcBef>
+                <a:spcPts val="0"/>
+              </a:spcBef>
+              <a:spcAft>
+                <a:spcPts val="400"/>
+              </a:spcAft>
+            </a:pPr>
+            <a:r>
+              <a:rPr sz="1150" b="0" i="0">
+                <a:solidFill>
+                  <a:srgbClr val="333333"/>
+                </a:solidFill>
+                <a:latin typeface="Calibri"/>
+              </a:rPr>
+              <a:t>Azure Advisor</a:t>
+            </a:r>
+          </a:p>
+        </p:txBody>
+      </p:sp>
+      <p:sp>
+        <p:nvSpPr>
+          <p:cNvPr id="18" name="TextBox 17"/>
+          <p:cNvSpPr txBox="1"/>
+          <p:nvPr/>
+        </p:nvSpPr>
+        <p:spPr>
+          <a:xfrm>
+            <a:off x="8229600" y="3310128"/>
+            <a:ext cx="3474720" cy="411480"/>
+          </a:xfrm>
+          <a:prstGeom prst="rect">
+            <a:avLst/>
+          </a:prstGeom>
+          <a:noFill/>
+        </p:spPr>
+        <p:txBody>
+          <a:bodyPr wrap="square">
+            <a:spAutoFit/>
+          </a:bodyPr>
+          <a:lstStyle/>
+          <a:p>
+            <a:pPr algn="l">
+              <a:spcBef>
+                <a:spcPts val="0"/>
+              </a:spcBef>
+              <a:spcAft>
+                <a:spcPts val="400"/>
+              </a:spcAft>
+            </a:pPr>
+            <a:r>
+              <a:rPr sz="1150" b="0" i="0">
+                <a:solidFill>
+                  <a:srgbClr val="333333"/>
+                </a:solidFill>
+                <a:latin typeface="Calibri"/>
+              </a:rPr>
+              <a:t>Trusted Advisor · Compute Optimizer</a:t>
+            </a:r>
+          </a:p>
+        </p:txBody>
+      </p:sp>
+      <p:sp>
+        <p:nvSpPr>
+          <p:cNvPr id="19" name="Rectangle 18"/>
+          <p:cNvSpPr/>
+          <p:nvPr/>
+        </p:nvSpPr>
+        <p:spPr>
+          <a:xfrm>
+            <a:off x="640080" y="3831336"/>
+            <a:ext cx="109728" cy="502920"/>
+          </a:xfrm>
+          <a:prstGeom prst="rect">
+            <a:avLst/>
+          </a:prstGeom>
+          <a:solidFill>
+            <a:srgbClr val="1E7C3C"/>
+          </a:solidFill>
+          <a:ln>
+            <a:noFill/>
+          </a:ln>
+          <a:effectLst/>
+        </p:spPr>
+        <p:style>
+          <a:lnRef idx="1">
+            <a:schemeClr val="accent1"/>
+          </a:lnRef>
+          <a:fillRef idx="3">
+            <a:schemeClr val="accent1"/>
+          </a:fillRef>
+          <a:effectRef idx="2">
+            <a:schemeClr val="accent1"/>
+          </a:effectRef>
+          <a:fontRef idx="minor">
+            <a:schemeClr val="lt1"/>
+          </a:fontRef>
+        </p:style>
+        <p:txBody>
+          <a:bodyPr rtlCol="0" anchor="ctr"/>
+          <a:lstStyle/>
+          <a:p>
+            <a:pPr algn="ctr"/>
+          </a:p>
+        </p:txBody>
+      </p:sp>
+      <p:sp>
+        <p:nvSpPr>
+          <p:cNvPr id="20" name="TextBox 19"/>
+          <p:cNvSpPr txBox="1"/>
+          <p:nvPr/>
+        </p:nvSpPr>
+        <p:spPr>
+          <a:xfrm>
+            <a:off x="868680" y="3886200"/>
+            <a:ext cx="3794760" cy="411480"/>
+          </a:xfrm>
+          <a:prstGeom prst="rect">
+            <a:avLst/>
+          </a:prstGeom>
+          <a:noFill/>
+        </p:spPr>
+        <p:txBody>
+          <a:bodyPr wrap="square">
+            <a:spAutoFit/>
+          </a:bodyPr>
+          <a:lstStyle/>
+          <a:p>
+            <a:pPr algn="l">
+              <a:spcBef>
+                <a:spcPts val="0"/>
+              </a:spcBef>
+              <a:spcAft>
+                <a:spcPts val="400"/>
+              </a:spcAft>
+            </a:pPr>
+            <a:r>
+              <a:rPr sz="1250" b="1" i="0">
+                <a:solidFill>
+                  <a:srgbClr val="333333"/>
+                </a:solidFill>
+                <a:latin typeface="Calibri"/>
+              </a:rPr>
+              <a:t>Estimar antes de crear</a:t>
+            </a:r>
+          </a:p>
+        </p:txBody>
+      </p:sp>
+      <p:sp>
+        <p:nvSpPr>
+          <p:cNvPr id="21" name="TextBox 20"/>
+          <p:cNvSpPr txBox="1"/>
+          <p:nvPr/>
+        </p:nvSpPr>
+        <p:spPr>
+          <a:xfrm>
+            <a:off x="4754880" y="3886200"/>
+            <a:ext cx="3383280" cy="411480"/>
+          </a:xfrm>
+          <a:prstGeom prst="rect">
+            <a:avLst/>
+          </a:prstGeom>
+          <a:noFill/>
+        </p:spPr>
+        <p:txBody>
+          <a:bodyPr wrap="square">
+            <a:spAutoFit/>
+          </a:bodyPr>
+          <a:lstStyle/>
+          <a:p>
+            <a:pPr algn="l">
+              <a:spcBef>
+                <a:spcPts val="0"/>
+              </a:spcBef>
+              <a:spcAft>
+                <a:spcPts val="400"/>
+              </a:spcAft>
+            </a:pPr>
+            <a:r>
+              <a:rPr sz="1150" b="0" i="0">
+                <a:solidFill>
+                  <a:srgbClr val="333333"/>
+                </a:solidFill>
+                <a:latin typeface="Calibri"/>
+              </a:rPr>
+              <a:t>Pricing Calculator</a:t>
+            </a:r>
+          </a:p>
+        </p:txBody>
+      </p:sp>
+      <p:sp>
+        <p:nvSpPr>
+          <p:cNvPr id="22" name="TextBox 21"/>
+          <p:cNvSpPr txBox="1"/>
+          <p:nvPr/>
+        </p:nvSpPr>
+        <p:spPr>
+          <a:xfrm>
+            <a:off x="8229600" y="3886200"/>
+            <a:ext cx="3474720" cy="411480"/>
+          </a:xfrm>
+          <a:prstGeom prst="rect">
+            <a:avLst/>
+          </a:prstGeom>
+          <a:noFill/>
+        </p:spPr>
+        <p:txBody>
+          <a:bodyPr wrap="square">
+            <a:spAutoFit/>
+          </a:bodyPr>
+          <a:lstStyle/>
+          <a:p>
+            <a:pPr algn="l">
+              <a:spcBef>
+                <a:spcPts val="0"/>
+              </a:spcBef>
+              <a:spcAft>
+                <a:spcPts val="400"/>
+              </a:spcAft>
+            </a:pPr>
+            <a:r>
+              <a:rPr sz="1150" b="0" i="0">
+                <a:solidFill>
+                  <a:srgbClr val="333333"/>
+                </a:solidFill>
+                <a:latin typeface="Calibri"/>
+              </a:rPr>
+              <a:t>AWS Pricing Calculator</a:t>
+            </a:r>
+          </a:p>
+        </p:txBody>
+      </p:sp>
+      <p:sp>
+        <p:nvSpPr>
+          <p:cNvPr id="23" name="Rectangle 22"/>
+          <p:cNvSpPr/>
+          <p:nvPr/>
+        </p:nvSpPr>
+        <p:spPr>
+          <a:xfrm>
+            <a:off x="640080" y="4407408"/>
+            <a:ext cx="109728" cy="502920"/>
+          </a:xfrm>
+          <a:prstGeom prst="rect">
+            <a:avLst/>
+          </a:prstGeom>
+          <a:solidFill>
+            <a:srgbClr val="1E7C3C"/>
+          </a:solidFill>
+          <a:ln>
+            <a:noFill/>
+          </a:ln>
+          <a:effectLst/>
+        </p:spPr>
+        <p:style>
+          <a:lnRef idx="1">
+            <a:schemeClr val="accent1"/>
+          </a:lnRef>
+          <a:fillRef idx="3">
+            <a:schemeClr val="accent1"/>
+          </a:fillRef>
+          <a:effectRef idx="2">
+            <a:schemeClr val="accent1"/>
+          </a:effectRef>
+          <a:fontRef idx="minor">
+            <a:schemeClr val="lt1"/>
+          </a:fontRef>
+        </p:style>
+        <p:txBody>
+          <a:bodyPr rtlCol="0" anchor="ctr"/>
+          <a:lstStyle/>
+          <a:p>
+            <a:pPr algn="ctr"/>
+          </a:p>
+        </p:txBody>
+      </p:sp>
+      <p:sp>
+        <p:nvSpPr>
+          <p:cNvPr id="24" name="TextBox 23"/>
+          <p:cNvSpPr txBox="1"/>
+          <p:nvPr/>
+        </p:nvSpPr>
+        <p:spPr>
+          <a:xfrm>
+            <a:off x="868680" y="4462272"/>
+            <a:ext cx="3794760" cy="411480"/>
+          </a:xfrm>
+          <a:prstGeom prst="rect">
+            <a:avLst/>
+          </a:prstGeom>
+          <a:noFill/>
+        </p:spPr>
+        <p:txBody>
+          <a:bodyPr wrap="square">
+            <a:spAutoFit/>
+          </a:bodyPr>
+          <a:lstStyle/>
+          <a:p>
+            <a:pPr algn="l">
+              <a:spcBef>
+                <a:spcPts val="0"/>
+              </a:spcBef>
+              <a:spcAft>
+                <a:spcPts val="400"/>
+              </a:spcAft>
+            </a:pPr>
+            <a:r>
+              <a:rPr sz="1250" b="1" i="0">
+                <a:solidFill>
+                  <a:srgbClr val="333333"/>
+                </a:solidFill>
+                <a:latin typeface="Calibri"/>
+              </a:rPr>
+              <a:t>Etiquetar para asignar</a:t>
+            </a:r>
+          </a:p>
+        </p:txBody>
+      </p:sp>
+      <p:sp>
+        <p:nvSpPr>
+          <p:cNvPr id="25" name="TextBox 24"/>
+          <p:cNvSpPr txBox="1"/>
+          <p:nvPr/>
+        </p:nvSpPr>
+        <p:spPr>
+          <a:xfrm>
+            <a:off x="4754880" y="4462272"/>
+            <a:ext cx="3383280" cy="411480"/>
+          </a:xfrm>
+          <a:prstGeom prst="rect">
+            <a:avLst/>
+          </a:prstGeom>
+          <a:noFill/>
+        </p:spPr>
+        <p:txBody>
+          <a:bodyPr wrap="square">
+            <a:spAutoFit/>
+          </a:bodyPr>
+          <a:lstStyle/>
+          <a:p>
+            <a:pPr algn="l">
+              <a:spcBef>
+                <a:spcPts val="0"/>
+              </a:spcBef>
+              <a:spcAft>
+                <a:spcPts val="400"/>
+              </a:spcAft>
+            </a:pPr>
+            <a:r>
+              <a:rPr sz="1150" b="0" i="0">
+                <a:solidFill>
+                  <a:srgbClr val="333333"/>
+                </a:solidFill>
+                <a:latin typeface="Calibri"/>
+              </a:rPr>
+              <a:t>Tags</a:t>
+            </a:r>
+          </a:p>
+        </p:txBody>
+      </p:sp>
+      <p:sp>
+        <p:nvSpPr>
+          <p:cNvPr id="26" name="TextBox 25"/>
+          <p:cNvSpPr txBox="1"/>
+          <p:nvPr/>
+        </p:nvSpPr>
+        <p:spPr>
+          <a:xfrm>
+            <a:off x="8229600" y="4462272"/>
+            <a:ext cx="3474720" cy="411480"/>
+          </a:xfrm>
+          <a:prstGeom prst="rect">
+            <a:avLst/>
+          </a:prstGeom>
+          <a:noFill/>
+        </p:spPr>
+        <p:txBody>
+          <a:bodyPr wrap="square">
+            <a:spAutoFit/>
+          </a:bodyPr>
+          <a:lstStyle/>
+          <a:p>
+            <a:pPr algn="l">
+              <a:spcBef>
+                <a:spcPts val="0"/>
+              </a:spcBef>
+              <a:spcAft>
+                <a:spcPts val="400"/>
+              </a:spcAft>
+            </a:pPr>
+            <a:r>
+              <a:rPr sz="1150" b="0" i="0">
+                <a:solidFill>
+                  <a:srgbClr val="333333"/>
+                </a:solidFill>
+                <a:latin typeface="Calibri"/>
+              </a:rPr>
+              <a:t>Cost Allocation Tags</a:t>
+            </a:r>
+          </a:p>
+        </p:txBody>
+      </p:sp>
+      <p:sp>
+        <p:nvSpPr>
+          <p:cNvPr id="27" name="Rectangle 26"/>
+          <p:cNvSpPr/>
+          <p:nvPr/>
+        </p:nvSpPr>
+        <p:spPr>
+          <a:xfrm>
+            <a:off x="640080" y="4983480"/>
+            <a:ext cx="109728" cy="502920"/>
+          </a:xfrm>
+          <a:prstGeom prst="rect">
+            <a:avLst/>
+          </a:prstGeom>
+          <a:solidFill>
+            <a:srgbClr val="1E7C3C"/>
+          </a:solidFill>
+          <a:ln>
+            <a:noFill/>
+          </a:ln>
+          <a:effectLst/>
+        </p:spPr>
+        <p:style>
+          <a:lnRef idx="1">
+            <a:schemeClr val="accent1"/>
+          </a:lnRef>
+          <a:fillRef idx="3">
+            <a:schemeClr val="accent1"/>
+          </a:fillRef>
+          <a:effectRef idx="2">
+            <a:schemeClr val="accent1"/>
+          </a:effectRef>
+          <a:fontRef idx="minor">
+            <a:schemeClr val="lt1"/>
+          </a:fontRef>
+        </p:style>
+        <p:txBody>
+          <a:bodyPr rtlCol="0" anchor="ctr"/>
+          <a:lstStyle/>
+          <a:p>
+            <a:pPr algn="ctr"/>
+          </a:p>
+        </p:txBody>
+      </p:sp>
+      <p:sp>
+        <p:nvSpPr>
+          <p:cNvPr id="28" name="TextBox 27"/>
+          <p:cNvSpPr txBox="1"/>
+          <p:nvPr/>
+        </p:nvSpPr>
+        <p:spPr>
+          <a:xfrm>
+            <a:off x="868680" y="5038344"/>
+            <a:ext cx="3794760" cy="411480"/>
+          </a:xfrm>
+          <a:prstGeom prst="rect">
+            <a:avLst/>
+          </a:prstGeom>
+          <a:noFill/>
+        </p:spPr>
+        <p:txBody>
+          <a:bodyPr wrap="square">
+            <a:spAutoFit/>
+          </a:bodyPr>
+          <a:lstStyle/>
+          <a:p>
+            <a:pPr algn="l">
+              <a:spcBef>
+                <a:spcPts val="0"/>
+              </a:spcBef>
+              <a:spcAft>
+                <a:spcPts val="400"/>
+              </a:spcAft>
+            </a:pPr>
+            <a:r>
+              <a:rPr sz="1250" b="1" i="0">
+                <a:solidFill>
+                  <a:srgbClr val="333333"/>
+                </a:solidFill>
+                <a:latin typeface="Calibri"/>
+              </a:rPr>
+              <a:t>Comprar con descuento</a:t>
+            </a:r>
+          </a:p>
+        </p:txBody>
+      </p:sp>
+      <p:sp>
+        <p:nvSpPr>
+          <p:cNvPr id="29" name="TextBox 28"/>
+          <p:cNvSpPr txBox="1"/>
+          <p:nvPr/>
+        </p:nvSpPr>
+        <p:spPr>
+          <a:xfrm>
+            <a:off x="4754880" y="5038344"/>
+            <a:ext cx="3383280" cy="411480"/>
+          </a:xfrm>
+          <a:prstGeom prst="rect">
+            <a:avLst/>
+          </a:prstGeom>
+          <a:noFill/>
+        </p:spPr>
+        <p:txBody>
+          <a:bodyPr wrap="square">
+            <a:spAutoFit/>
+          </a:bodyPr>
+          <a:lstStyle/>
+          <a:p>
+            <a:pPr algn="l">
+              <a:spcBef>
+                <a:spcPts val="0"/>
+              </a:spcBef>
+              <a:spcAft>
+                <a:spcPts val="400"/>
+              </a:spcAft>
+            </a:pPr>
+            <a:r>
+              <a:rPr sz="1150" b="0" i="0">
+                <a:solidFill>
+                  <a:srgbClr val="333333"/>
+                </a:solidFill>
+                <a:latin typeface="Calibri"/>
+              </a:rPr>
+              <a:t>Reservations · Savings Plans</a:t>
+            </a:r>
+          </a:p>
+        </p:txBody>
+      </p:sp>
+      <p:sp>
+        <p:nvSpPr>
+          <p:cNvPr id="30" name="TextBox 29"/>
+          <p:cNvSpPr txBox="1"/>
+          <p:nvPr/>
+        </p:nvSpPr>
+        <p:spPr>
+          <a:xfrm>
+            <a:off x="8229600" y="5038344"/>
+            <a:ext cx="3474720" cy="411480"/>
+          </a:xfrm>
+          <a:prstGeom prst="rect">
+            <a:avLst/>
+          </a:prstGeom>
+          <a:noFill/>
+        </p:spPr>
+        <p:txBody>
+          <a:bodyPr wrap="square">
+            <a:spAutoFit/>
+          </a:bodyPr>
+          <a:lstStyle/>
+          <a:p>
+            <a:pPr algn="l">
+              <a:spcBef>
+                <a:spcPts val="0"/>
+              </a:spcBef>
+              <a:spcAft>
+                <a:spcPts val="400"/>
+              </a:spcAft>
+            </a:pPr>
+            <a:r>
+              <a:rPr sz="1150" b="0" i="0">
+                <a:solidFill>
+                  <a:srgbClr val="333333"/>
+                </a:solidFill>
+                <a:latin typeface="Calibri"/>
+              </a:rPr>
+              <a:t>Reserved Instances · Savings Plans</a:t>
+            </a:r>
+          </a:p>
+        </p:txBody>
+      </p:sp>
+      <p:sp>
+        <p:nvSpPr>
+          <p:cNvPr id="31" name="TextBox 30"/>
+          <p:cNvSpPr txBox="1"/>
+          <p:nvPr/>
+        </p:nvSpPr>
+        <p:spPr>
+          <a:xfrm>
+            <a:off x="640080" y="5715000"/>
+            <a:ext cx="10972800" cy="548640"/>
+          </a:xfrm>
+          <a:prstGeom prst="rect">
+            <a:avLst/>
+          </a:prstGeom>
+          <a:noFill/>
+        </p:spPr>
+        <p:txBody>
+          <a:bodyPr wrap="square">
+            <a:spAutoFit/>
+          </a:bodyPr>
+          <a:lstStyle/>
+          <a:p>
+            <a:pPr algn="l">
+              <a:spcBef>
+                <a:spcPts val="0"/>
+              </a:spcBef>
+              <a:spcAft>
+                <a:spcPts val="400"/>
+              </a:spcAft>
+            </a:pPr>
+            <a:r>
+              <a:rPr sz="1250" b="0" i="1">
+                <a:solidFill>
+                  <a:srgbClr val="333333"/>
+                </a:solidFill>
+                <a:latin typeface="Calibri"/>
+              </a:rPr>
+              <a:t>Las herramientas cambian de nombre; el framework Informar → Optimizar → Operar es idéntico. Un practicante de FinOps se mueve entre nubes: lo que aprendes aquí en Azure lo aplicas en AWS.</a:t>
+            </a:r>
+          </a:p>
+        </p:txBody>
+      </p:sp>
+      <p:sp>
+        <p:nvSpPr>
+          <p:cNvPr id="32" name="TextBox 31"/>
           <p:cNvSpPr txBox="1"/>
           <p:nvPr/>
         </p:nvSpPr>
@@ -5327,6 +6327,2147 @@
                 </a:solidFill>
                 <a:latin typeface="Calibri"/>
               </a:rPr>
+              <a:t>Caso de uso: el recurso olvidado (zombie)</a:t>
+            </a:r>
+          </a:p>
+        </p:txBody>
+      </p:sp>
+      <p:sp>
+        <p:nvSpPr>
+          <p:cNvPr id="3" name="TextBox 2"/>
+          <p:cNvSpPr txBox="1"/>
+          <p:nvPr/>
+        </p:nvSpPr>
+        <p:spPr>
+          <a:xfrm>
+            <a:off x="502920" y="896112"/>
+            <a:ext cx="11155680" cy="457200"/>
+          </a:xfrm>
+          <a:prstGeom prst="rect">
+            <a:avLst/>
+          </a:prstGeom>
+          <a:noFill/>
+        </p:spPr>
+        <p:txBody>
+          <a:bodyPr wrap="square">
+            <a:spAutoFit/>
+          </a:bodyPr>
+          <a:lstStyle/>
+          <a:p>
+            <a:pPr algn="l">
+              <a:spcBef>
+                <a:spcPts val="0"/>
+              </a:spcBef>
+              <a:spcAft>
+                <a:spcPts val="400"/>
+              </a:spcAft>
+            </a:pPr>
+            <a:r>
+              <a:rPr sz="1500" b="1" i="0">
+                <a:solidFill>
+                  <a:srgbClr val="1F3864"/>
+                </a:solidFill>
+                <a:latin typeface="Calibri"/>
+              </a:rPr>
+              <a:t>El desperdicio #1 en la nube — y cómo el ciclo FinOps lo resuelve</a:t>
+            </a:r>
+          </a:p>
+        </p:txBody>
+      </p:sp>
+      <p:sp>
+        <p:nvSpPr>
+          <p:cNvPr id="4" name="Rounded Rectangle 3"/>
+          <p:cNvSpPr/>
+          <p:nvPr/>
+        </p:nvSpPr>
+        <p:spPr>
+          <a:xfrm>
+            <a:off x="502920" y="1737360"/>
+            <a:ext cx="2011680" cy="960120"/>
+          </a:xfrm>
+          <a:prstGeom prst="roundRect">
+            <a:avLst>
+              <a:gd name="adj" fmla="val 6000"/>
+            </a:avLst>
+          </a:prstGeom>
+          <a:solidFill>
+            <a:srgbClr val="1F4E9C"/>
+          </a:solidFill>
+          <a:ln>
+            <a:noFill/>
+          </a:ln>
+          <a:effectLst/>
+        </p:spPr>
+        <p:style>
+          <a:lnRef idx="1">
+            <a:schemeClr val="accent1"/>
+          </a:lnRef>
+          <a:fillRef idx="3">
+            <a:schemeClr val="accent1"/>
+          </a:fillRef>
+          <a:effectRef idx="2">
+            <a:schemeClr val="accent1"/>
+          </a:effectRef>
+          <a:fontRef idx="minor">
+            <a:schemeClr val="lt1"/>
+          </a:fontRef>
+        </p:style>
+        <p:txBody>
+          <a:bodyPr rtlCol="0" anchor="ctr" lIns="54864" rIns="54864" wrap="square"/>
+          <a:lstStyle/>
+          <a:p>
+            <a:pPr algn="ctr">
+              <a:spcBef>
+                <a:spcPts val="0"/>
+              </a:spcBef>
+              <a:spcAft>
+                <a:spcPts val="200"/>
+              </a:spcAft>
+            </a:pPr>
+            <a:r>
+              <a:rPr sz="1300" b="1" i="0">
+                <a:solidFill>
+                  <a:srgbClr val="FFFFFF"/>
+                </a:solidFill>
+                <a:latin typeface="Calibri"/>
+              </a:rPr>
+              <a:t>SE CREA</a:t>
+            </a:r>
+          </a:p>
+          <a:p>
+            <a:pPr algn="ctr">
+              <a:spcBef>
+                <a:spcPts val="0"/>
+              </a:spcBef>
+              <a:spcAft>
+                <a:spcPts val="400"/>
+              </a:spcAft>
+            </a:pPr>
+            <a:r>
+              <a:rPr sz="1000" b="0" i="0">
+                <a:solidFill>
+                  <a:srgbClr val="FFFFFF"/>
+                </a:solidFill>
+                <a:latin typeface="Calibri"/>
+              </a:rPr>
+              <a:t>una VM para una prueba</a:t>
+            </a:r>
+          </a:p>
+        </p:txBody>
+      </p:sp>
+      <p:sp>
+        <p:nvSpPr>
+          <p:cNvPr id="5" name="Right Arrow 4"/>
+          <p:cNvSpPr/>
+          <p:nvPr/>
+        </p:nvSpPr>
+        <p:spPr>
+          <a:xfrm>
+            <a:off x="2532888" y="2075688"/>
+            <a:ext cx="219456" cy="274320"/>
+          </a:xfrm>
+          <a:prstGeom prst="rightArrow">
+            <a:avLst/>
+          </a:prstGeom>
+          <a:solidFill>
+            <a:srgbClr val="9DB2C8"/>
+          </a:solidFill>
+          <a:ln>
+            <a:noFill/>
+          </a:ln>
+          <a:effectLst/>
+        </p:spPr>
+        <p:style>
+          <a:lnRef idx="1">
+            <a:schemeClr val="accent1"/>
+          </a:lnRef>
+          <a:fillRef idx="3">
+            <a:schemeClr val="accent1"/>
+          </a:fillRef>
+          <a:effectRef idx="2">
+            <a:schemeClr val="accent1"/>
+          </a:effectRef>
+          <a:fontRef idx="minor">
+            <a:schemeClr val="lt1"/>
+          </a:fontRef>
+        </p:style>
+        <p:txBody>
+          <a:bodyPr rtlCol="0" anchor="ctr"/>
+          <a:lstStyle/>
+          <a:p>
+            <a:pPr algn="ctr"/>
+          </a:p>
+        </p:txBody>
+      </p:sp>
+      <p:sp>
+        <p:nvSpPr>
+          <p:cNvPr id="6" name="Rounded Rectangle 5"/>
+          <p:cNvSpPr/>
+          <p:nvPr/>
+        </p:nvSpPr>
+        <p:spPr>
+          <a:xfrm>
+            <a:off x="2761488" y="1737360"/>
+            <a:ext cx="2011680" cy="960120"/>
+          </a:xfrm>
+          <a:prstGeom prst="roundRect">
+            <a:avLst>
+              <a:gd name="adj" fmla="val 6000"/>
+            </a:avLst>
+          </a:prstGeom>
+          <a:solidFill>
+            <a:srgbClr val="B02A26"/>
+          </a:solidFill>
+          <a:ln>
+            <a:noFill/>
+          </a:ln>
+          <a:effectLst/>
+        </p:spPr>
+        <p:style>
+          <a:lnRef idx="1">
+            <a:schemeClr val="accent1"/>
+          </a:lnRef>
+          <a:fillRef idx="3">
+            <a:schemeClr val="accent1"/>
+          </a:fillRef>
+          <a:effectRef idx="2">
+            <a:schemeClr val="accent1"/>
+          </a:effectRef>
+          <a:fontRef idx="minor">
+            <a:schemeClr val="lt1"/>
+          </a:fontRef>
+        </p:style>
+        <p:txBody>
+          <a:bodyPr rtlCol="0" anchor="ctr" lIns="54864" rIns="54864" wrap="square"/>
+          <a:lstStyle/>
+          <a:p>
+            <a:pPr algn="ctr">
+              <a:spcBef>
+                <a:spcPts val="0"/>
+              </a:spcBef>
+              <a:spcAft>
+                <a:spcPts val="200"/>
+              </a:spcAft>
+            </a:pPr>
+            <a:r>
+              <a:rPr sz="1300" b="1" i="0">
+                <a:solidFill>
+                  <a:srgbClr val="FFFFFF"/>
+                </a:solidFill>
+                <a:latin typeface="Calibri"/>
+              </a:rPr>
+              <a:t>SE OLVIDA</a:t>
+            </a:r>
+          </a:p>
+          <a:p>
+            <a:pPr algn="ctr">
+              <a:spcBef>
+                <a:spcPts val="0"/>
+              </a:spcBef>
+              <a:spcAft>
+                <a:spcPts val="400"/>
+              </a:spcAft>
+            </a:pPr>
+            <a:r>
+              <a:rPr sz="1000" b="0" i="0">
+                <a:solidFill>
+                  <a:srgbClr val="FFFFFF"/>
+                </a:solidFill>
+                <a:latin typeface="Calibri"/>
+              </a:rPr>
+              <a:t>encendida sin uso; la factura sube</a:t>
+            </a:r>
+          </a:p>
+        </p:txBody>
+      </p:sp>
+      <p:sp>
+        <p:nvSpPr>
+          <p:cNvPr id="7" name="Right Arrow 6"/>
+          <p:cNvSpPr/>
+          <p:nvPr/>
+        </p:nvSpPr>
+        <p:spPr>
+          <a:xfrm>
+            <a:off x="4791456" y="2075688"/>
+            <a:ext cx="219456" cy="274320"/>
+          </a:xfrm>
+          <a:prstGeom prst="rightArrow">
+            <a:avLst/>
+          </a:prstGeom>
+          <a:solidFill>
+            <a:srgbClr val="9DB2C8"/>
+          </a:solidFill>
+          <a:ln>
+            <a:noFill/>
+          </a:ln>
+          <a:effectLst/>
+        </p:spPr>
+        <p:style>
+          <a:lnRef idx="1">
+            <a:schemeClr val="accent1"/>
+          </a:lnRef>
+          <a:fillRef idx="3">
+            <a:schemeClr val="accent1"/>
+          </a:fillRef>
+          <a:effectRef idx="2">
+            <a:schemeClr val="accent1"/>
+          </a:effectRef>
+          <a:fontRef idx="minor">
+            <a:schemeClr val="lt1"/>
+          </a:fontRef>
+        </p:style>
+        <p:txBody>
+          <a:bodyPr rtlCol="0" anchor="ctr"/>
+          <a:lstStyle/>
+          <a:p>
+            <a:pPr algn="ctr"/>
+          </a:p>
+        </p:txBody>
+      </p:sp>
+      <p:sp>
+        <p:nvSpPr>
+          <p:cNvPr id="8" name="Rounded Rectangle 7"/>
+          <p:cNvSpPr/>
+          <p:nvPr/>
+        </p:nvSpPr>
+        <p:spPr>
+          <a:xfrm>
+            <a:off x="5020056" y="1737360"/>
+            <a:ext cx="2011680" cy="960120"/>
+          </a:xfrm>
+          <a:prstGeom prst="roundRect">
+            <a:avLst>
+              <a:gd name="adj" fmla="val 6000"/>
+            </a:avLst>
+          </a:prstGeom>
+          <a:solidFill>
+            <a:srgbClr val="17808A"/>
+          </a:solidFill>
+          <a:ln>
+            <a:noFill/>
+          </a:ln>
+          <a:effectLst/>
+        </p:spPr>
+        <p:style>
+          <a:lnRef idx="1">
+            <a:schemeClr val="accent1"/>
+          </a:lnRef>
+          <a:fillRef idx="3">
+            <a:schemeClr val="accent1"/>
+          </a:fillRef>
+          <a:effectRef idx="2">
+            <a:schemeClr val="accent1"/>
+          </a:effectRef>
+          <a:fontRef idx="minor">
+            <a:schemeClr val="lt1"/>
+          </a:fontRef>
+        </p:style>
+        <p:txBody>
+          <a:bodyPr rtlCol="0" anchor="ctr" lIns="54864" rIns="54864" wrap="square"/>
+          <a:lstStyle/>
+          <a:p>
+            <a:pPr algn="ctr">
+              <a:spcBef>
+                <a:spcPts val="0"/>
+              </a:spcBef>
+              <a:spcAft>
+                <a:spcPts val="200"/>
+              </a:spcAft>
+            </a:pPr>
+            <a:r>
+              <a:rPr sz="1300" b="1" i="0">
+                <a:solidFill>
+                  <a:srgbClr val="FFFFFF"/>
+                </a:solidFill>
+                <a:latin typeface="Calibri"/>
+              </a:rPr>
+              <a:t>SE DETECTA</a:t>
+            </a:r>
+          </a:p>
+          <a:p>
+            <a:pPr algn="ctr">
+              <a:spcBef>
+                <a:spcPts val="0"/>
+              </a:spcBef>
+              <a:spcAft>
+                <a:spcPts val="400"/>
+              </a:spcAft>
+            </a:pPr>
+            <a:r>
+              <a:rPr sz="1000" b="0" i="0">
+                <a:solidFill>
+                  <a:srgbClr val="FFFFFF"/>
+                </a:solidFill>
+                <a:latin typeface="Calibri"/>
+              </a:rPr>
+              <a:t>Cost Analysis / Cost Explorer</a:t>
+            </a:r>
+          </a:p>
+        </p:txBody>
+      </p:sp>
+      <p:sp>
+        <p:nvSpPr>
+          <p:cNvPr id="9" name="Right Arrow 8"/>
+          <p:cNvSpPr/>
+          <p:nvPr/>
+        </p:nvSpPr>
+        <p:spPr>
+          <a:xfrm>
+            <a:off x="7050024" y="2075688"/>
+            <a:ext cx="219456" cy="274320"/>
+          </a:xfrm>
+          <a:prstGeom prst="rightArrow">
+            <a:avLst/>
+          </a:prstGeom>
+          <a:solidFill>
+            <a:srgbClr val="9DB2C8"/>
+          </a:solidFill>
+          <a:ln>
+            <a:noFill/>
+          </a:ln>
+          <a:effectLst/>
+        </p:spPr>
+        <p:style>
+          <a:lnRef idx="1">
+            <a:schemeClr val="accent1"/>
+          </a:lnRef>
+          <a:fillRef idx="3">
+            <a:schemeClr val="accent1"/>
+          </a:fillRef>
+          <a:effectRef idx="2">
+            <a:schemeClr val="accent1"/>
+          </a:effectRef>
+          <a:fontRef idx="minor">
+            <a:schemeClr val="lt1"/>
+          </a:fontRef>
+        </p:style>
+        <p:txBody>
+          <a:bodyPr rtlCol="0" anchor="ctr"/>
+          <a:lstStyle/>
+          <a:p>
+            <a:pPr algn="ctr"/>
+          </a:p>
+        </p:txBody>
+      </p:sp>
+      <p:sp>
+        <p:nvSpPr>
+          <p:cNvPr id="10" name="Rounded Rectangle 9"/>
+          <p:cNvSpPr/>
+          <p:nvPr/>
+        </p:nvSpPr>
+        <p:spPr>
+          <a:xfrm>
+            <a:off x="7278624" y="1737360"/>
+            <a:ext cx="2011680" cy="960120"/>
+          </a:xfrm>
+          <a:prstGeom prst="roundRect">
+            <a:avLst>
+              <a:gd name="adj" fmla="val 6000"/>
+            </a:avLst>
+          </a:prstGeom>
+          <a:solidFill>
+            <a:srgbClr val="8A6D1F"/>
+          </a:solidFill>
+          <a:ln>
+            <a:noFill/>
+          </a:ln>
+          <a:effectLst/>
+        </p:spPr>
+        <p:style>
+          <a:lnRef idx="1">
+            <a:schemeClr val="accent1"/>
+          </a:lnRef>
+          <a:fillRef idx="3">
+            <a:schemeClr val="accent1"/>
+          </a:fillRef>
+          <a:effectRef idx="2">
+            <a:schemeClr val="accent1"/>
+          </a:effectRef>
+          <a:fontRef idx="minor">
+            <a:schemeClr val="lt1"/>
+          </a:fontRef>
+        </p:style>
+        <p:txBody>
+          <a:bodyPr rtlCol="0" anchor="ctr" lIns="54864" rIns="54864" wrap="square"/>
+          <a:lstStyle/>
+          <a:p>
+            <a:pPr algn="ctr">
+              <a:spcBef>
+                <a:spcPts val="0"/>
+              </a:spcBef>
+              <a:spcAft>
+                <a:spcPts val="200"/>
+              </a:spcAft>
+            </a:pPr>
+            <a:r>
+              <a:rPr sz="1300" b="1" i="0">
+                <a:solidFill>
+                  <a:srgbClr val="FFFFFF"/>
+                </a:solidFill>
+                <a:latin typeface="Calibri"/>
+              </a:rPr>
+              <a:t>SE CONFIRMA</a:t>
+            </a:r>
+          </a:p>
+          <a:p>
+            <a:pPr algn="ctr">
+              <a:spcBef>
+                <a:spcPts val="0"/>
+              </a:spcBef>
+              <a:spcAft>
+                <a:spcPts val="400"/>
+              </a:spcAft>
+            </a:pPr>
+            <a:r>
+              <a:rPr sz="1000" b="0" i="0">
+                <a:solidFill>
+                  <a:srgbClr val="FFFFFF"/>
+                </a:solidFill>
+                <a:latin typeface="Calibri"/>
+              </a:rPr>
+              <a:t>Advisor / Compute Optimizer</a:t>
+            </a:r>
+          </a:p>
+        </p:txBody>
+      </p:sp>
+      <p:sp>
+        <p:nvSpPr>
+          <p:cNvPr id="11" name="Right Arrow 10"/>
+          <p:cNvSpPr/>
+          <p:nvPr/>
+        </p:nvSpPr>
+        <p:spPr>
+          <a:xfrm>
+            <a:off x="9308592" y="2075688"/>
+            <a:ext cx="219456" cy="274320"/>
+          </a:xfrm>
+          <a:prstGeom prst="rightArrow">
+            <a:avLst/>
+          </a:prstGeom>
+          <a:solidFill>
+            <a:srgbClr val="9DB2C8"/>
+          </a:solidFill>
+          <a:ln>
+            <a:noFill/>
+          </a:ln>
+          <a:effectLst/>
+        </p:spPr>
+        <p:style>
+          <a:lnRef idx="1">
+            <a:schemeClr val="accent1"/>
+          </a:lnRef>
+          <a:fillRef idx="3">
+            <a:schemeClr val="accent1"/>
+          </a:fillRef>
+          <a:effectRef idx="2">
+            <a:schemeClr val="accent1"/>
+          </a:effectRef>
+          <a:fontRef idx="minor">
+            <a:schemeClr val="lt1"/>
+          </a:fontRef>
+        </p:style>
+        <p:txBody>
+          <a:bodyPr rtlCol="0" anchor="ctr"/>
+          <a:lstStyle/>
+          <a:p>
+            <a:pPr algn="ctr"/>
+          </a:p>
+        </p:txBody>
+      </p:sp>
+      <p:sp>
+        <p:nvSpPr>
+          <p:cNvPr id="12" name="Rounded Rectangle 11"/>
+          <p:cNvSpPr/>
+          <p:nvPr/>
+        </p:nvSpPr>
+        <p:spPr>
+          <a:xfrm>
+            <a:off x="9537192" y="1737360"/>
+            <a:ext cx="2011680" cy="960120"/>
+          </a:xfrm>
+          <a:prstGeom prst="roundRect">
+            <a:avLst>
+              <a:gd name="adj" fmla="val 6000"/>
+            </a:avLst>
+          </a:prstGeom>
+          <a:solidFill>
+            <a:srgbClr val="1E7C3C"/>
+          </a:solidFill>
+          <a:ln>
+            <a:noFill/>
+          </a:ln>
+          <a:effectLst/>
+        </p:spPr>
+        <p:style>
+          <a:lnRef idx="1">
+            <a:schemeClr val="accent1"/>
+          </a:lnRef>
+          <a:fillRef idx="3">
+            <a:schemeClr val="accent1"/>
+          </a:fillRef>
+          <a:effectRef idx="2">
+            <a:schemeClr val="accent1"/>
+          </a:effectRef>
+          <a:fontRef idx="minor">
+            <a:schemeClr val="lt1"/>
+          </a:fontRef>
+        </p:style>
+        <p:txBody>
+          <a:bodyPr rtlCol="0" anchor="ctr" lIns="54864" rIns="54864" wrap="square"/>
+          <a:lstStyle/>
+          <a:p>
+            <a:pPr algn="ctr">
+              <a:spcBef>
+                <a:spcPts val="0"/>
+              </a:spcBef>
+              <a:spcAft>
+                <a:spcPts val="200"/>
+              </a:spcAft>
+            </a:pPr>
+            <a:r>
+              <a:rPr sz="1300" b="1" i="0">
+                <a:solidFill>
+                  <a:srgbClr val="FFFFFF"/>
+                </a:solidFill>
+                <a:latin typeface="Calibri"/>
+              </a:rPr>
+              <a:t>SE APAGA</a:t>
+            </a:r>
+          </a:p>
+          <a:p>
+            <a:pPr algn="ctr">
+              <a:spcBef>
+                <a:spcPts val="0"/>
+              </a:spcBef>
+              <a:spcAft>
+                <a:spcPts val="400"/>
+              </a:spcAft>
+            </a:pPr>
+            <a:r>
+              <a:rPr sz="1000" b="0" i="0">
+                <a:solidFill>
+                  <a:srgbClr val="FFFFFF"/>
+                </a:solidFill>
+                <a:latin typeface="Calibri"/>
+              </a:rPr>
+              <a:t>y se verifica el ahorro</a:t>
+            </a:r>
+          </a:p>
+        </p:txBody>
+      </p:sp>
+      <p:pic>
+        <p:nvPicPr>
+          <p:cNvPr id="13" name="Picture 12" descr="serverroom.jpg"/>
+          <p:cNvPicPr>
+            <a:picLocks noChangeAspect="1"/>
+          </p:cNvPicPr>
+          <p:nvPr/>
+        </p:nvPicPr>
+        <p:blipFill>
+          <a:blip r:embed="rId2"/>
+          <a:stretch>
+            <a:fillRect/>
+          </a:stretch>
+        </p:blipFill>
+        <p:spPr>
+          <a:xfrm>
+            <a:off x="502920" y="3108960"/>
+            <a:ext cx="3931920" cy="2621280"/>
+          </a:xfrm>
+          <a:prstGeom prst="rect">
+            <a:avLst/>
+          </a:prstGeom>
+        </p:spPr>
+      </p:pic>
+      <p:sp>
+        <p:nvSpPr>
+          <p:cNvPr id="14" name="TextBox 13"/>
+          <p:cNvSpPr txBox="1"/>
+          <p:nvPr/>
+        </p:nvSpPr>
+        <p:spPr>
+          <a:xfrm>
+            <a:off x="502920" y="5760720"/>
+            <a:ext cx="4023360" cy="274320"/>
+          </a:xfrm>
+          <a:prstGeom prst="rect">
+            <a:avLst/>
+          </a:prstGeom>
+          <a:noFill/>
+        </p:spPr>
+        <p:txBody>
+          <a:bodyPr wrap="square">
+            <a:spAutoFit/>
+          </a:bodyPr>
+          <a:lstStyle/>
+          <a:p>
+            <a:pPr algn="l">
+              <a:spcBef>
+                <a:spcPts val="0"/>
+              </a:spcBef>
+              <a:spcAft>
+                <a:spcPts val="400"/>
+              </a:spcAft>
+            </a:pPr>
+            <a:r>
+              <a:rPr sz="800" b="0" i="0">
+                <a:solidFill>
+                  <a:srgbClr val="595959"/>
+                </a:solidFill>
+                <a:latin typeface="Calibri"/>
+              </a:rPr>
+              <a:t>Racks de servidores · Wikimedia Commons · CC BY 4.0</a:t>
+            </a:r>
+          </a:p>
+        </p:txBody>
+      </p:sp>
+      <p:sp>
+        <p:nvSpPr>
+          <p:cNvPr id="15" name="TextBox 14"/>
+          <p:cNvSpPr txBox="1"/>
+          <p:nvPr/>
+        </p:nvSpPr>
+        <p:spPr>
+          <a:xfrm>
+            <a:off x="4754880" y="3200400"/>
+            <a:ext cx="6858000" cy="2926080"/>
+          </a:xfrm>
+          <a:prstGeom prst="rect">
+            <a:avLst/>
+          </a:prstGeom>
+          <a:noFill/>
+        </p:spPr>
+        <p:txBody>
+          <a:bodyPr wrap="square">
+            <a:spAutoFit/>
+          </a:bodyPr>
+          <a:lstStyle/>
+          <a:p>
+            <a:pPr algn="l">
+              <a:spcBef>
+                <a:spcPts val="0"/>
+              </a:spcBef>
+              <a:spcAft>
+                <a:spcPts val="800"/>
+              </a:spcAft>
+            </a:pPr>
+            <a:r>
+              <a:rPr sz="1400" b="1" i="0">
+                <a:solidFill>
+                  <a:srgbClr val="1F3864"/>
+                </a:solidFill>
+                <a:latin typeface="Calibri"/>
+              </a:rPr>
+              <a:t>Lo mismo en las dos nubes:</a:t>
+            </a:r>
+          </a:p>
+          <a:p>
+            <a:pPr algn="l" indent="-137160" marL="182880">
+              <a:spcBef>
+                <a:spcPts val="0"/>
+              </a:spcBef>
+              <a:spcAft>
+                <a:spcPts val="700"/>
+              </a:spcAft>
+              <a:buChar char="•"/>
+            </a:pPr>
+            <a:r>
+              <a:rPr sz="1300" b="0" i="0">
+                <a:solidFill>
+                  <a:srgbClr val="333333"/>
+                </a:solidFill>
+                <a:latin typeface="Calibri"/>
+              </a:rPr>
+              <a:t>Azure: una VM olvidada → la ves en Cost Analysis, Advisor la marca como infrautilizada, la apagas o la eliminas.</a:t>
+            </a:r>
+          </a:p>
+          <a:p>
+            <a:pPr algn="l" indent="-137160" marL="182880">
+              <a:spcBef>
+                <a:spcPts val="0"/>
+              </a:spcBef>
+              <a:spcAft>
+                <a:spcPts val="700"/>
+              </a:spcAft>
+              <a:buChar char="•"/>
+            </a:pPr>
+            <a:r>
+              <a:rPr sz="1300" b="0" i="0">
+                <a:solidFill>
+                  <a:srgbClr val="333333"/>
+                </a:solidFill>
+                <a:latin typeface="Calibri"/>
+              </a:rPr>
+              <a:t>AWS: una instancia EC2 igual → Cost Explorer muestra el gasto, Compute Optimizer / Trusted Advisor la marcan, la detienes.</a:t>
+            </a:r>
+          </a:p>
+          <a:p>
+            <a:pPr algn="l" indent="-137160" marL="182880">
+              <a:spcBef>
+                <a:spcPts val="0"/>
+              </a:spcBef>
+              <a:spcAft>
+                <a:spcPts val="400"/>
+              </a:spcAft>
+              <a:buChar char="•"/>
+            </a:pPr>
+            <a:r>
+              <a:rPr sz="1300" b="0" i="0">
+                <a:solidFill>
+                  <a:srgbClr val="1E7C3C"/>
+                </a:solidFill>
+                <a:latin typeface="Calibri"/>
+              </a:rPr>
+              <a:t>La lección FinOps: apagar lo que no se usa es el ahorro más fácil y frecuente. Pagas por tiempo encendido, uses o no la máquina.</a:t>
+            </a:r>
+          </a:p>
+        </p:txBody>
+      </p:sp>
+      <p:sp>
+        <p:nvSpPr>
+          <p:cNvPr id="16" name="TextBox 15"/>
+          <p:cNvSpPr txBox="1"/>
+          <p:nvPr/>
+        </p:nvSpPr>
+        <p:spPr>
+          <a:xfrm>
+            <a:off x="502920" y="6473952"/>
+            <a:ext cx="10972800" cy="320040"/>
+          </a:xfrm>
+          <a:prstGeom prst="rect">
+            <a:avLst/>
+          </a:prstGeom>
+          <a:noFill/>
+        </p:spPr>
+        <p:txBody>
+          <a:bodyPr wrap="square">
+            <a:spAutoFit/>
+          </a:bodyPr>
+          <a:lstStyle/>
+          <a:p>
+            <a:pPr algn="l">
+              <a:spcBef>
+                <a:spcPts val="0"/>
+              </a:spcBef>
+              <a:spcAft>
+                <a:spcPts val="400"/>
+              </a:spcAft>
+            </a:pPr>
+            <a:r>
+              <a:rPr sz="1000" b="1" i="0">
+                <a:solidFill>
+                  <a:srgbClr val="008542"/>
+                </a:solidFill>
+                <a:latin typeface="Calibri"/>
+              </a:rPr>
+              <a:t>ean  ·  educación continua   |   88-EAN · FinOps y Optimización de Costos Cloud · Sesión 1</a:t>
+            </a:r>
+          </a:p>
+        </p:txBody>
+      </p:sp>
+    </p:spTree>
+  </p:cSld>
+  <p:clrMapOvr>
+    <a:masterClrMapping/>
+  </p:clrMapOvr>
+</p:sld>
+</file>
+
+<file path=ppt/slides/slide14.xml><?xml version="1.0" encoding="utf-8"?>
+<p:sld xmlns:a="http://schemas.openxmlformats.org/drawingml/2006/main" xmlns:p="http://schemas.openxmlformats.org/presentationml/2006/main" xmlns:r="http://schemas.openxmlformats.org/officeDocument/2006/relationships">
+  <p:cSld>
+    <p:spTree>
+      <p:nvGrpSpPr>
+        <p:cNvPr id="1" name=""/>
+        <p:cNvGrpSpPr/>
+        <p:nvPr/>
+      </p:nvGrpSpPr>
+      <p:grpSpPr/>
+      <p:sp>
+        <p:nvSpPr>
+          <p:cNvPr id="2" name="TextBox 1"/>
+          <p:cNvSpPr txBox="1"/>
+          <p:nvPr/>
+        </p:nvSpPr>
+        <p:spPr>
+          <a:xfrm>
+            <a:off x="502920" y="292608"/>
+            <a:ext cx="11155680" cy="685800"/>
+          </a:xfrm>
+          <a:prstGeom prst="rect">
+            <a:avLst/>
+          </a:prstGeom>
+          <a:noFill/>
+        </p:spPr>
+        <p:txBody>
+          <a:bodyPr wrap="square">
+            <a:spAutoFit/>
+          </a:bodyPr>
+          <a:lstStyle/>
+          <a:p>
+            <a:pPr algn="l">
+              <a:spcBef>
+                <a:spcPts val="0"/>
+              </a:spcBef>
+              <a:spcAft>
+                <a:spcPts val="400"/>
+              </a:spcAft>
+            </a:pPr>
+            <a:r>
+              <a:rPr sz="2900" b="1" i="0">
+                <a:solidFill>
+                  <a:srgbClr val="1A1A1A"/>
+                </a:solidFill>
+                <a:latin typeface="Calibri"/>
+              </a:rPr>
+              <a:t>Caso de uso: la sorpresa de la salida de datos</a:t>
+            </a:r>
+          </a:p>
+        </p:txBody>
+      </p:sp>
+      <p:sp>
+        <p:nvSpPr>
+          <p:cNvPr id="3" name="TextBox 2"/>
+          <p:cNvSpPr txBox="1"/>
+          <p:nvPr/>
+        </p:nvSpPr>
+        <p:spPr>
+          <a:xfrm>
+            <a:off x="502920" y="896112"/>
+            <a:ext cx="11155680" cy="457200"/>
+          </a:xfrm>
+          <a:prstGeom prst="rect">
+            <a:avLst/>
+          </a:prstGeom>
+          <a:noFill/>
+        </p:spPr>
+        <p:txBody>
+          <a:bodyPr wrap="square">
+            <a:spAutoFit/>
+          </a:bodyPr>
+          <a:lstStyle/>
+          <a:p>
+            <a:pPr algn="l">
+              <a:spcBef>
+                <a:spcPts val="0"/>
+              </a:spcBef>
+              <a:spcAft>
+                <a:spcPts val="400"/>
+              </a:spcAft>
+            </a:pPr>
+            <a:r>
+              <a:rPr sz="1500" b="1" i="0">
+                <a:solidFill>
+                  <a:srgbClr val="1F3864"/>
+                </a:solidFill>
+                <a:latin typeface="Calibri"/>
+              </a:rPr>
+              <a:t>La entrada es gratis; SACAR datos se cobra — sorprende en Azure y en AWS</a:t>
+            </a:r>
+          </a:p>
+        </p:txBody>
+      </p:sp>
+      <p:sp>
+        <p:nvSpPr>
+          <p:cNvPr id="4" name="Rounded Rectangle 3"/>
+          <p:cNvSpPr/>
+          <p:nvPr/>
+        </p:nvSpPr>
+        <p:spPr>
+          <a:xfrm>
+            <a:off x="502920" y="1737360"/>
+            <a:ext cx="2011680" cy="960120"/>
+          </a:xfrm>
+          <a:prstGeom prst="roundRect">
+            <a:avLst>
+              <a:gd name="adj" fmla="val 6000"/>
+            </a:avLst>
+          </a:prstGeom>
+          <a:solidFill>
+            <a:srgbClr val="1F4E9C"/>
+          </a:solidFill>
+          <a:ln>
+            <a:noFill/>
+          </a:ln>
+          <a:effectLst/>
+        </p:spPr>
+        <p:style>
+          <a:lnRef idx="1">
+            <a:schemeClr val="accent1"/>
+          </a:lnRef>
+          <a:fillRef idx="3">
+            <a:schemeClr val="accent1"/>
+          </a:fillRef>
+          <a:effectRef idx="2">
+            <a:schemeClr val="accent1"/>
+          </a:effectRef>
+          <a:fontRef idx="minor">
+            <a:schemeClr val="lt1"/>
+          </a:fontRef>
+        </p:style>
+        <p:txBody>
+          <a:bodyPr rtlCol="0" anchor="ctr" lIns="54864" rIns="54864" wrap="square"/>
+          <a:lstStyle/>
+          <a:p>
+            <a:pPr algn="ctr">
+              <a:spcBef>
+                <a:spcPts val="0"/>
+              </a:spcBef>
+              <a:spcAft>
+                <a:spcPts val="200"/>
+              </a:spcAft>
+            </a:pPr>
+            <a:r>
+              <a:rPr sz="1300" b="1" i="0">
+                <a:solidFill>
+                  <a:srgbClr val="FFFFFF"/>
+                </a:solidFill>
+                <a:latin typeface="Calibri"/>
+              </a:rPr>
+              <a:t>APP EN LA NUBE</a:t>
+            </a:r>
+          </a:p>
+          <a:p>
+            <a:pPr algn="ctr">
+              <a:spcBef>
+                <a:spcPts val="0"/>
+              </a:spcBef>
+              <a:spcAft>
+                <a:spcPts val="400"/>
+              </a:spcAft>
+            </a:pPr>
+            <a:r>
+              <a:rPr sz="1000" b="0" i="0">
+                <a:solidFill>
+                  <a:srgbClr val="FFFFFF"/>
+                </a:solidFill>
+                <a:latin typeface="Calibri"/>
+              </a:rPr>
+              <a:t>sirve datos a usuarios/otras regiones</a:t>
+            </a:r>
+          </a:p>
+        </p:txBody>
+      </p:sp>
+      <p:sp>
+        <p:nvSpPr>
+          <p:cNvPr id="5" name="Right Arrow 4"/>
+          <p:cNvSpPr/>
+          <p:nvPr/>
+        </p:nvSpPr>
+        <p:spPr>
+          <a:xfrm>
+            <a:off x="2532888" y="2075688"/>
+            <a:ext cx="219456" cy="274320"/>
+          </a:xfrm>
+          <a:prstGeom prst="rightArrow">
+            <a:avLst/>
+          </a:prstGeom>
+          <a:solidFill>
+            <a:srgbClr val="9DB2C8"/>
+          </a:solidFill>
+          <a:ln>
+            <a:noFill/>
+          </a:ln>
+          <a:effectLst/>
+        </p:spPr>
+        <p:style>
+          <a:lnRef idx="1">
+            <a:schemeClr val="accent1"/>
+          </a:lnRef>
+          <a:fillRef idx="3">
+            <a:schemeClr val="accent1"/>
+          </a:fillRef>
+          <a:effectRef idx="2">
+            <a:schemeClr val="accent1"/>
+          </a:effectRef>
+          <a:fontRef idx="minor">
+            <a:schemeClr val="lt1"/>
+          </a:fontRef>
+        </p:style>
+        <p:txBody>
+          <a:bodyPr rtlCol="0" anchor="ctr"/>
+          <a:lstStyle/>
+          <a:p>
+            <a:pPr algn="ctr"/>
+          </a:p>
+        </p:txBody>
+      </p:sp>
+      <p:sp>
+        <p:nvSpPr>
+          <p:cNvPr id="6" name="Rounded Rectangle 5"/>
+          <p:cNvSpPr/>
+          <p:nvPr/>
+        </p:nvSpPr>
+        <p:spPr>
+          <a:xfrm>
+            <a:off x="2761488" y="1737360"/>
+            <a:ext cx="2011680" cy="960120"/>
+          </a:xfrm>
+          <a:prstGeom prst="roundRect">
+            <a:avLst>
+              <a:gd name="adj" fmla="val 6000"/>
+            </a:avLst>
+          </a:prstGeom>
+          <a:solidFill>
+            <a:srgbClr val="8A6D1F"/>
+          </a:solidFill>
+          <a:ln>
+            <a:noFill/>
+          </a:ln>
+          <a:effectLst/>
+        </p:spPr>
+        <p:style>
+          <a:lnRef idx="1">
+            <a:schemeClr val="accent1"/>
+          </a:lnRef>
+          <a:fillRef idx="3">
+            <a:schemeClr val="accent1"/>
+          </a:fillRef>
+          <a:effectRef idx="2">
+            <a:schemeClr val="accent1"/>
+          </a:effectRef>
+          <a:fontRef idx="minor">
+            <a:schemeClr val="lt1"/>
+          </a:fontRef>
+        </p:style>
+        <p:txBody>
+          <a:bodyPr rtlCol="0" anchor="ctr" lIns="54864" rIns="54864" wrap="square"/>
+          <a:lstStyle/>
+          <a:p>
+            <a:pPr algn="ctr">
+              <a:spcBef>
+                <a:spcPts val="0"/>
+              </a:spcBef>
+              <a:spcAft>
+                <a:spcPts val="200"/>
+              </a:spcAft>
+            </a:pPr>
+            <a:r>
+              <a:rPr sz="1300" b="1" i="0">
+                <a:solidFill>
+                  <a:srgbClr val="FFFFFF"/>
+                </a:solidFill>
+                <a:latin typeface="Calibri"/>
+              </a:rPr>
+              <a:t>SALEN DATOS</a:t>
+            </a:r>
+          </a:p>
+          <a:p>
+            <a:pPr algn="ctr">
+              <a:spcBef>
+                <a:spcPts val="0"/>
+              </a:spcBef>
+              <a:spcAft>
+                <a:spcPts val="400"/>
+              </a:spcAft>
+            </a:pPr>
+            <a:r>
+              <a:rPr sz="1000" b="0" i="0">
+                <a:solidFill>
+                  <a:srgbClr val="FFFFFF"/>
+                </a:solidFill>
+                <a:latin typeface="Calibri"/>
+              </a:rPr>
+              <a:t>cada GB de egress se cobra</a:t>
+            </a:r>
+          </a:p>
+        </p:txBody>
+      </p:sp>
+      <p:sp>
+        <p:nvSpPr>
+          <p:cNvPr id="7" name="Right Arrow 6"/>
+          <p:cNvSpPr/>
+          <p:nvPr/>
+        </p:nvSpPr>
+        <p:spPr>
+          <a:xfrm>
+            <a:off x="4791456" y="2075688"/>
+            <a:ext cx="219456" cy="274320"/>
+          </a:xfrm>
+          <a:prstGeom prst="rightArrow">
+            <a:avLst/>
+          </a:prstGeom>
+          <a:solidFill>
+            <a:srgbClr val="9DB2C8"/>
+          </a:solidFill>
+          <a:ln>
+            <a:noFill/>
+          </a:ln>
+          <a:effectLst/>
+        </p:spPr>
+        <p:style>
+          <a:lnRef idx="1">
+            <a:schemeClr val="accent1"/>
+          </a:lnRef>
+          <a:fillRef idx="3">
+            <a:schemeClr val="accent1"/>
+          </a:fillRef>
+          <a:effectRef idx="2">
+            <a:schemeClr val="accent1"/>
+          </a:effectRef>
+          <a:fontRef idx="minor">
+            <a:schemeClr val="lt1"/>
+          </a:fontRef>
+        </p:style>
+        <p:txBody>
+          <a:bodyPr rtlCol="0" anchor="ctr"/>
+          <a:lstStyle/>
+          <a:p>
+            <a:pPr algn="ctr"/>
+          </a:p>
+        </p:txBody>
+      </p:sp>
+      <p:sp>
+        <p:nvSpPr>
+          <p:cNvPr id="8" name="Rounded Rectangle 7"/>
+          <p:cNvSpPr/>
+          <p:nvPr/>
+        </p:nvSpPr>
+        <p:spPr>
+          <a:xfrm>
+            <a:off x="5020056" y="1737360"/>
+            <a:ext cx="2011680" cy="960120"/>
+          </a:xfrm>
+          <a:prstGeom prst="roundRect">
+            <a:avLst>
+              <a:gd name="adj" fmla="val 6000"/>
+            </a:avLst>
+          </a:prstGeom>
+          <a:solidFill>
+            <a:srgbClr val="B02A26"/>
+          </a:solidFill>
+          <a:ln>
+            <a:noFill/>
+          </a:ln>
+          <a:effectLst/>
+        </p:spPr>
+        <p:style>
+          <a:lnRef idx="1">
+            <a:schemeClr val="accent1"/>
+          </a:lnRef>
+          <a:fillRef idx="3">
+            <a:schemeClr val="accent1"/>
+          </a:fillRef>
+          <a:effectRef idx="2">
+            <a:schemeClr val="accent1"/>
+          </a:effectRef>
+          <a:fontRef idx="minor">
+            <a:schemeClr val="lt1"/>
+          </a:fontRef>
+        </p:style>
+        <p:txBody>
+          <a:bodyPr rtlCol="0" anchor="ctr" lIns="54864" rIns="54864" wrap="square"/>
+          <a:lstStyle/>
+          <a:p>
+            <a:pPr algn="ctr">
+              <a:spcBef>
+                <a:spcPts val="0"/>
+              </a:spcBef>
+              <a:spcAft>
+                <a:spcPts val="200"/>
+              </a:spcAft>
+            </a:pPr>
+            <a:r>
+              <a:rPr sz="1300" b="1" i="0">
+                <a:solidFill>
+                  <a:srgbClr val="FFFFFF"/>
+                </a:solidFill>
+                <a:latin typeface="Calibri"/>
+              </a:rPr>
+              <a:t>PICO EN LA FACTURA</a:t>
+            </a:r>
+          </a:p>
+          <a:p>
+            <a:pPr algn="ctr">
+              <a:spcBef>
+                <a:spcPts val="0"/>
+              </a:spcBef>
+              <a:spcAft>
+                <a:spcPts val="400"/>
+              </a:spcAft>
+            </a:pPr>
+            <a:r>
+              <a:rPr sz="1000" b="0" i="0">
+                <a:solidFill>
+                  <a:srgbClr val="FFFFFF"/>
+                </a:solidFill>
+                <a:latin typeface="Calibri"/>
+              </a:rPr>
+              <a:t>un cargo que nadie esperaba</a:t>
+            </a:r>
+          </a:p>
+        </p:txBody>
+      </p:sp>
+      <p:sp>
+        <p:nvSpPr>
+          <p:cNvPr id="9" name="Right Arrow 8"/>
+          <p:cNvSpPr/>
+          <p:nvPr/>
+        </p:nvSpPr>
+        <p:spPr>
+          <a:xfrm>
+            <a:off x="7050024" y="2075688"/>
+            <a:ext cx="219456" cy="274320"/>
+          </a:xfrm>
+          <a:prstGeom prst="rightArrow">
+            <a:avLst/>
+          </a:prstGeom>
+          <a:solidFill>
+            <a:srgbClr val="9DB2C8"/>
+          </a:solidFill>
+          <a:ln>
+            <a:noFill/>
+          </a:ln>
+          <a:effectLst/>
+        </p:spPr>
+        <p:style>
+          <a:lnRef idx="1">
+            <a:schemeClr val="accent1"/>
+          </a:lnRef>
+          <a:fillRef idx="3">
+            <a:schemeClr val="accent1"/>
+          </a:fillRef>
+          <a:effectRef idx="2">
+            <a:schemeClr val="accent1"/>
+          </a:effectRef>
+          <a:fontRef idx="minor">
+            <a:schemeClr val="lt1"/>
+          </a:fontRef>
+        </p:style>
+        <p:txBody>
+          <a:bodyPr rtlCol="0" anchor="ctr"/>
+          <a:lstStyle/>
+          <a:p>
+            <a:pPr algn="ctr"/>
+          </a:p>
+        </p:txBody>
+      </p:sp>
+      <p:sp>
+        <p:nvSpPr>
+          <p:cNvPr id="10" name="Rounded Rectangle 9"/>
+          <p:cNvSpPr/>
+          <p:nvPr/>
+        </p:nvSpPr>
+        <p:spPr>
+          <a:xfrm>
+            <a:off x="7278624" y="1737360"/>
+            <a:ext cx="2011680" cy="960120"/>
+          </a:xfrm>
+          <a:prstGeom prst="roundRect">
+            <a:avLst>
+              <a:gd name="adj" fmla="val 6000"/>
+            </a:avLst>
+          </a:prstGeom>
+          <a:solidFill>
+            <a:srgbClr val="17808A"/>
+          </a:solidFill>
+          <a:ln>
+            <a:noFill/>
+          </a:ln>
+          <a:effectLst/>
+        </p:spPr>
+        <p:style>
+          <a:lnRef idx="1">
+            <a:schemeClr val="accent1"/>
+          </a:lnRef>
+          <a:fillRef idx="3">
+            <a:schemeClr val="accent1"/>
+          </a:fillRef>
+          <a:effectRef idx="2">
+            <a:schemeClr val="accent1"/>
+          </a:effectRef>
+          <a:fontRef idx="minor">
+            <a:schemeClr val="lt1"/>
+          </a:fontRef>
+        </p:style>
+        <p:txBody>
+          <a:bodyPr rtlCol="0" anchor="ctr" lIns="54864" rIns="54864" wrap="square"/>
+          <a:lstStyle/>
+          <a:p>
+            <a:pPr algn="ctr">
+              <a:spcBef>
+                <a:spcPts val="0"/>
+              </a:spcBef>
+              <a:spcAft>
+                <a:spcPts val="200"/>
+              </a:spcAft>
+            </a:pPr>
+            <a:r>
+              <a:rPr sz="1300" b="1" i="0">
+                <a:solidFill>
+                  <a:srgbClr val="FFFFFF"/>
+                </a:solidFill>
+                <a:latin typeface="Calibri"/>
+              </a:rPr>
+              <a:t>SE DETECTA</a:t>
+            </a:r>
+          </a:p>
+          <a:p>
+            <a:pPr algn="ctr">
+              <a:spcBef>
+                <a:spcPts val="0"/>
+              </a:spcBef>
+              <a:spcAft>
+                <a:spcPts val="400"/>
+              </a:spcAft>
+            </a:pPr>
+            <a:r>
+              <a:rPr sz="1000" b="0" i="0">
+                <a:solidFill>
+                  <a:srgbClr val="FFFFFF"/>
+                </a:solidFill>
+                <a:latin typeface="Calibri"/>
+              </a:rPr>
+              <a:t>costo por medidor: 'Data Transfer Out'</a:t>
+            </a:r>
+          </a:p>
+        </p:txBody>
+      </p:sp>
+      <p:sp>
+        <p:nvSpPr>
+          <p:cNvPr id="11" name="Right Arrow 10"/>
+          <p:cNvSpPr/>
+          <p:nvPr/>
+        </p:nvSpPr>
+        <p:spPr>
+          <a:xfrm>
+            <a:off x="9308592" y="2075688"/>
+            <a:ext cx="219456" cy="274320"/>
+          </a:xfrm>
+          <a:prstGeom prst="rightArrow">
+            <a:avLst/>
+          </a:prstGeom>
+          <a:solidFill>
+            <a:srgbClr val="9DB2C8"/>
+          </a:solidFill>
+          <a:ln>
+            <a:noFill/>
+          </a:ln>
+          <a:effectLst/>
+        </p:spPr>
+        <p:style>
+          <a:lnRef idx="1">
+            <a:schemeClr val="accent1"/>
+          </a:lnRef>
+          <a:fillRef idx="3">
+            <a:schemeClr val="accent1"/>
+          </a:fillRef>
+          <a:effectRef idx="2">
+            <a:schemeClr val="accent1"/>
+          </a:effectRef>
+          <a:fontRef idx="minor">
+            <a:schemeClr val="lt1"/>
+          </a:fontRef>
+        </p:style>
+        <p:txBody>
+          <a:bodyPr rtlCol="0" anchor="ctr"/>
+          <a:lstStyle/>
+          <a:p>
+            <a:pPr algn="ctr"/>
+          </a:p>
+        </p:txBody>
+      </p:sp>
+      <p:sp>
+        <p:nvSpPr>
+          <p:cNvPr id="12" name="Rounded Rectangle 11"/>
+          <p:cNvSpPr/>
+          <p:nvPr/>
+        </p:nvSpPr>
+        <p:spPr>
+          <a:xfrm>
+            <a:off x="9537192" y="1737360"/>
+            <a:ext cx="2011680" cy="960120"/>
+          </a:xfrm>
+          <a:prstGeom prst="roundRect">
+            <a:avLst>
+              <a:gd name="adj" fmla="val 6000"/>
+            </a:avLst>
+          </a:prstGeom>
+          <a:solidFill>
+            <a:srgbClr val="1E7C3C"/>
+          </a:solidFill>
+          <a:ln>
+            <a:noFill/>
+          </a:ln>
+          <a:effectLst/>
+        </p:spPr>
+        <p:style>
+          <a:lnRef idx="1">
+            <a:schemeClr val="accent1"/>
+          </a:lnRef>
+          <a:fillRef idx="3">
+            <a:schemeClr val="accent1"/>
+          </a:fillRef>
+          <a:effectRef idx="2">
+            <a:schemeClr val="accent1"/>
+          </a:effectRef>
+          <a:fontRef idx="minor">
+            <a:schemeClr val="lt1"/>
+          </a:fontRef>
+        </p:style>
+        <p:txBody>
+          <a:bodyPr rtlCol="0" anchor="ctr" lIns="54864" rIns="54864" wrap="square"/>
+          <a:lstStyle/>
+          <a:p>
+            <a:pPr algn="ctr">
+              <a:spcBef>
+                <a:spcPts val="0"/>
+              </a:spcBef>
+              <a:spcAft>
+                <a:spcPts val="200"/>
+              </a:spcAft>
+            </a:pPr>
+            <a:r>
+              <a:rPr sz="1300" b="1" i="0">
+                <a:solidFill>
+                  <a:srgbClr val="FFFFFF"/>
+                </a:solidFill>
+                <a:latin typeface="Calibri"/>
+              </a:rPr>
+              <a:t>SE MITIGA</a:t>
+            </a:r>
+          </a:p>
+          <a:p>
+            <a:pPr algn="ctr">
+              <a:spcBef>
+                <a:spcPts val="0"/>
+              </a:spcBef>
+              <a:spcAft>
+                <a:spcPts val="400"/>
+              </a:spcAft>
+            </a:pPr>
+            <a:r>
+              <a:rPr sz="1000" b="0" i="0">
+                <a:solidFill>
+                  <a:srgbClr val="FFFFFF"/>
+                </a:solidFill>
+                <a:latin typeface="Calibri"/>
+              </a:rPr>
+              <a:t>CDN, misma región, comprimir</a:t>
+            </a:r>
+          </a:p>
+        </p:txBody>
+      </p:sp>
+      <p:pic>
+        <p:nvPicPr>
+          <p:cNvPr id="13" name="Picture 12" descr="datacenter.jpg"/>
+          <p:cNvPicPr>
+            <a:picLocks noChangeAspect="1"/>
+          </p:cNvPicPr>
+          <p:nvPr/>
+        </p:nvPicPr>
+        <p:blipFill>
+          <a:blip r:embed="rId2"/>
+          <a:stretch>
+            <a:fillRect/>
+          </a:stretch>
+        </p:blipFill>
+        <p:spPr>
+          <a:xfrm>
+            <a:off x="7635240" y="3200400"/>
+            <a:ext cx="3931920" cy="2611041"/>
+          </a:xfrm>
+          <a:prstGeom prst="rect">
+            <a:avLst/>
+          </a:prstGeom>
+        </p:spPr>
+      </p:pic>
+      <p:sp>
+        <p:nvSpPr>
+          <p:cNvPr id="14" name="TextBox 13"/>
+          <p:cNvSpPr txBox="1"/>
+          <p:nvPr/>
+        </p:nvSpPr>
+        <p:spPr>
+          <a:xfrm>
+            <a:off x="7635240" y="5806440"/>
+            <a:ext cx="4023360" cy="274320"/>
+          </a:xfrm>
+          <a:prstGeom prst="rect">
+            <a:avLst/>
+          </a:prstGeom>
+          <a:noFill/>
+        </p:spPr>
+        <p:txBody>
+          <a:bodyPr wrap="square">
+            <a:spAutoFit/>
+          </a:bodyPr>
+          <a:lstStyle/>
+          <a:p>
+            <a:pPr algn="l">
+              <a:spcBef>
+                <a:spcPts val="0"/>
+              </a:spcBef>
+              <a:spcAft>
+                <a:spcPts val="400"/>
+              </a:spcAft>
+            </a:pPr>
+            <a:r>
+              <a:rPr sz="800" b="0" i="0">
+                <a:solidFill>
+                  <a:srgbClr val="595959"/>
+                </a:solidFill>
+                <a:latin typeface="Calibri"/>
+              </a:rPr>
+              <a:t>Data center · Wikimedia Commons · CC BY-SA 3.0</a:t>
+            </a:r>
+          </a:p>
+        </p:txBody>
+      </p:sp>
+      <p:sp>
+        <p:nvSpPr>
+          <p:cNvPr id="15" name="TextBox 14"/>
+          <p:cNvSpPr txBox="1"/>
+          <p:nvPr/>
+        </p:nvSpPr>
+        <p:spPr>
+          <a:xfrm>
+            <a:off x="502920" y="3200400"/>
+            <a:ext cx="6858000" cy="2926080"/>
+          </a:xfrm>
+          <a:prstGeom prst="rect">
+            <a:avLst/>
+          </a:prstGeom>
+          <a:noFill/>
+        </p:spPr>
+        <p:txBody>
+          <a:bodyPr wrap="square">
+            <a:spAutoFit/>
+          </a:bodyPr>
+          <a:lstStyle/>
+          <a:p>
+            <a:pPr algn="l">
+              <a:spcBef>
+                <a:spcPts val="0"/>
+              </a:spcBef>
+              <a:spcAft>
+                <a:spcPts val="800"/>
+              </a:spcAft>
+            </a:pPr>
+            <a:r>
+              <a:rPr sz="1400" b="1" i="0">
+                <a:solidFill>
+                  <a:srgbClr val="1F3864"/>
+                </a:solidFill>
+                <a:latin typeface="Calibri"/>
+              </a:rPr>
+              <a:t>Por qué sorprende — en cualquier nube:</a:t>
+            </a:r>
+          </a:p>
+          <a:p>
+            <a:pPr algn="l" indent="-137160" marL="182880">
+              <a:spcBef>
+                <a:spcPts val="0"/>
+              </a:spcBef>
+              <a:spcAft>
+                <a:spcPts val="700"/>
+              </a:spcAft>
+              <a:buChar char="•"/>
+            </a:pPr>
+            <a:r>
+              <a:rPr sz="1300" b="0" i="0">
+                <a:solidFill>
+                  <a:srgbClr val="333333"/>
+                </a:solidFill>
+                <a:latin typeface="Calibri"/>
+              </a:rPr>
+              <a:t>Subir datos (ingress) suele ser gratis; bajarlos/enviarlos fuera (egress) se cobra por GB. Azure y AWS funcionan igual.</a:t>
+            </a:r>
+          </a:p>
+          <a:p>
+            <a:pPr algn="l" indent="-137160" marL="182880">
+              <a:spcBef>
+                <a:spcPts val="0"/>
+              </a:spcBef>
+              <a:spcAft>
+                <a:spcPts val="700"/>
+              </a:spcAft>
+              <a:buChar char="•"/>
+            </a:pPr>
+            <a:r>
+              <a:rPr sz="1300" b="0" i="0">
+                <a:solidFill>
+                  <a:srgbClr val="333333"/>
+                </a:solidFill>
+                <a:latin typeface="Calibri"/>
+              </a:rPr>
+              <a:t>Se dispara con backups a otra región, APIs muy consultadas, o mover datos entre nubes.</a:t>
+            </a:r>
+          </a:p>
+          <a:p>
+            <a:pPr algn="l" indent="-137160" marL="182880">
+              <a:spcBef>
+                <a:spcPts val="0"/>
+              </a:spcBef>
+              <a:spcAft>
+                <a:spcPts val="700"/>
+              </a:spcAft>
+              <a:buChar char="•"/>
+            </a:pPr>
+            <a:r>
+              <a:rPr sz="1300" b="0" i="0">
+                <a:solidFill>
+                  <a:srgbClr val="333333"/>
+                </a:solidFill>
+                <a:latin typeface="Calibri"/>
+              </a:rPr>
+              <a:t>Se detecta agrupando el costo por 'medidor' (Azure) o 'usage type' (AWS) y buscando 'Data Transfer Out'.</a:t>
+            </a:r>
+          </a:p>
+          <a:p>
+            <a:pPr algn="l" indent="-137160" marL="182880">
+              <a:spcBef>
+                <a:spcPts val="0"/>
+              </a:spcBef>
+              <a:spcAft>
+                <a:spcPts val="400"/>
+              </a:spcAft>
+              <a:buChar char="•"/>
+            </a:pPr>
+            <a:r>
+              <a:rPr sz="1300" b="0" i="0">
+                <a:solidFill>
+                  <a:srgbClr val="1E7C3C"/>
+                </a:solidFill>
+                <a:latin typeface="Calibri"/>
+              </a:rPr>
+              <a:t>Se mitiga: cachear con CDN, mantener el tráfico en la misma región y comprimir. Diseñar pensando en el egress.</a:t>
+            </a:r>
+          </a:p>
+        </p:txBody>
+      </p:sp>
+      <p:sp>
+        <p:nvSpPr>
+          <p:cNvPr id="16" name="TextBox 15"/>
+          <p:cNvSpPr txBox="1"/>
+          <p:nvPr/>
+        </p:nvSpPr>
+        <p:spPr>
+          <a:xfrm>
+            <a:off x="502920" y="6473952"/>
+            <a:ext cx="10972800" cy="320040"/>
+          </a:xfrm>
+          <a:prstGeom prst="rect">
+            <a:avLst/>
+          </a:prstGeom>
+          <a:noFill/>
+        </p:spPr>
+        <p:txBody>
+          <a:bodyPr wrap="square">
+            <a:spAutoFit/>
+          </a:bodyPr>
+          <a:lstStyle/>
+          <a:p>
+            <a:pPr algn="l">
+              <a:spcBef>
+                <a:spcPts val="0"/>
+              </a:spcBef>
+              <a:spcAft>
+                <a:spcPts val="400"/>
+              </a:spcAft>
+            </a:pPr>
+            <a:r>
+              <a:rPr sz="1000" b="1" i="0">
+                <a:solidFill>
+                  <a:srgbClr val="008542"/>
+                </a:solidFill>
+                <a:latin typeface="Calibri"/>
+              </a:rPr>
+              <a:t>ean  ·  educación continua   |   88-EAN · FinOps y Optimización de Costos Cloud · Sesión 1</a:t>
+            </a:r>
+          </a:p>
+        </p:txBody>
+      </p:sp>
+    </p:spTree>
+  </p:cSld>
+  <p:clrMapOvr>
+    <a:masterClrMapping/>
+  </p:clrMapOvr>
+</p:sld>
+</file>
+
+<file path=ppt/slides/slide15.xml><?xml version="1.0" encoding="utf-8"?>
+<p:sld xmlns:a="http://schemas.openxmlformats.org/drawingml/2006/main" xmlns:p="http://schemas.openxmlformats.org/presentationml/2006/main" xmlns:r="http://schemas.openxmlformats.org/officeDocument/2006/relationships">
+  <p:cSld>
+    <p:spTree>
+      <p:nvGrpSpPr>
+        <p:cNvPr id="1" name=""/>
+        <p:cNvGrpSpPr/>
+        <p:nvPr/>
+      </p:nvGrpSpPr>
+      <p:grpSpPr/>
+      <p:sp>
+        <p:nvSpPr>
+          <p:cNvPr id="2" name="TextBox 1"/>
+          <p:cNvSpPr txBox="1"/>
+          <p:nvPr/>
+        </p:nvSpPr>
+        <p:spPr>
+          <a:xfrm>
+            <a:off x="502920" y="292608"/>
+            <a:ext cx="11155680" cy="685800"/>
+          </a:xfrm>
+          <a:prstGeom prst="rect">
+            <a:avLst/>
+          </a:prstGeom>
+          <a:noFill/>
+        </p:spPr>
+        <p:txBody>
+          <a:bodyPr wrap="square">
+            <a:spAutoFit/>
+          </a:bodyPr>
+          <a:lstStyle/>
+          <a:p>
+            <a:pPr algn="l">
+              <a:spcBef>
+                <a:spcPts val="0"/>
+              </a:spcBef>
+              <a:spcAft>
+                <a:spcPts val="400"/>
+              </a:spcAft>
+            </a:pPr>
+            <a:r>
+              <a:rPr sz="2900" b="1" i="0">
+                <a:solidFill>
+                  <a:srgbClr val="1A1A1A"/>
+                </a:solidFill>
+                <a:latin typeface="Calibri"/>
+              </a:rPr>
+              <a:t>La regla de oro de la Sesión 1</a:t>
+            </a:r>
+          </a:p>
+        </p:txBody>
+      </p:sp>
+      <p:sp>
+        <p:nvSpPr>
+          <p:cNvPr id="3" name="TextBox 2"/>
+          <p:cNvSpPr txBox="1"/>
+          <p:nvPr/>
+        </p:nvSpPr>
+        <p:spPr>
+          <a:xfrm>
+            <a:off x="502920" y="896112"/>
+            <a:ext cx="11155680" cy="457200"/>
+          </a:xfrm>
+          <a:prstGeom prst="rect">
+            <a:avLst/>
+          </a:prstGeom>
+          <a:noFill/>
+        </p:spPr>
+        <p:txBody>
+          <a:bodyPr wrap="square">
+            <a:spAutoFit/>
+          </a:bodyPr>
+          <a:lstStyle/>
+          <a:p>
+            <a:pPr algn="l">
+              <a:spcBef>
+                <a:spcPts val="0"/>
+              </a:spcBef>
+              <a:spcAft>
+                <a:spcPts val="400"/>
+              </a:spcAft>
+            </a:pPr>
+            <a:r>
+              <a:rPr sz="1500" b="1" i="0">
+                <a:solidFill>
+                  <a:srgbClr val="1F3864"/>
+                </a:solidFill>
+                <a:latin typeface="Calibri"/>
+              </a:rPr>
+              <a:t>Con la que arranca todo el resto del curso</a:t>
+            </a:r>
+          </a:p>
+        </p:txBody>
+      </p:sp>
+      <p:sp>
+        <p:nvSpPr>
+          <p:cNvPr id="4" name="Rounded Rectangle 3"/>
+          <p:cNvSpPr/>
+          <p:nvPr/>
+        </p:nvSpPr>
+        <p:spPr>
+          <a:xfrm>
+            <a:off x="1280160" y="2103120"/>
+            <a:ext cx="9601200" cy="1554480"/>
+          </a:xfrm>
+          <a:prstGeom prst="roundRect">
+            <a:avLst>
+              <a:gd name="adj" fmla="val 6000"/>
+            </a:avLst>
+          </a:prstGeom>
+          <a:solidFill>
+            <a:srgbClr val="1F3864"/>
+          </a:solidFill>
+          <a:ln>
+            <a:noFill/>
+          </a:ln>
+          <a:effectLst/>
+        </p:spPr>
+        <p:style>
+          <a:lnRef idx="1">
+            <a:schemeClr val="accent1"/>
+          </a:lnRef>
+          <a:fillRef idx="3">
+            <a:schemeClr val="accent1"/>
+          </a:fillRef>
+          <a:effectRef idx="2">
+            <a:schemeClr val="accent1"/>
+          </a:effectRef>
+          <a:fontRef idx="minor">
+            <a:schemeClr val="lt1"/>
+          </a:fontRef>
+        </p:style>
+        <p:txBody>
+          <a:bodyPr rtlCol="0" anchor="ctr" lIns="548640" rIns="457200" wrap="square"/>
+          <a:lstStyle/>
+          <a:p>
+            <a:pPr algn="l">
+              <a:spcBef>
+                <a:spcPts val="0"/>
+              </a:spcBef>
+              <a:spcAft>
+                <a:spcPts val="400"/>
+              </a:spcAft>
+            </a:pPr>
+            <a:r>
+              <a:rPr sz="1800" b="1" i="1">
+                <a:solidFill>
+                  <a:srgbClr val="FFFFFF"/>
+                </a:solidFill>
+                <a:latin typeface="Calibri"/>
+              </a:rPr>
+              <a:t>«No puedes optimizar —ni gobernar, ni presupuestar— lo que no puedes ver. La visibilidad del costo es el cimiento de FinOps.»</a:t>
+            </a:r>
+          </a:p>
+        </p:txBody>
+      </p:sp>
+      <p:sp>
+        <p:nvSpPr>
+          <p:cNvPr id="5" name="TextBox 4"/>
+          <p:cNvSpPr txBox="1"/>
+          <p:nvPr/>
+        </p:nvSpPr>
+        <p:spPr>
+          <a:xfrm>
+            <a:off x="1280160" y="4114800"/>
+            <a:ext cx="9692640" cy="457200"/>
+          </a:xfrm>
+          <a:prstGeom prst="rect">
+            <a:avLst/>
+          </a:prstGeom>
+          <a:noFill/>
+        </p:spPr>
+        <p:txBody>
+          <a:bodyPr wrap="square">
+            <a:spAutoFit/>
+          </a:bodyPr>
+          <a:lstStyle/>
+          <a:p>
+            <a:pPr algn="l" indent="-137160" marL="182880">
+              <a:spcBef>
+                <a:spcPts val="0"/>
+              </a:spcBef>
+              <a:spcAft>
+                <a:spcPts val="400"/>
+              </a:spcAft>
+              <a:buChar char="•"/>
+            </a:pPr>
+            <a:r>
+              <a:rPr sz="1350" b="0" i="0">
+                <a:solidFill>
+                  <a:srgbClr val="333333"/>
+                </a:solidFill>
+                <a:latin typeface="Calibri"/>
+              </a:rPr>
+              <a:t>Por eso INFORMAR es la primera fase del framework.</a:t>
+            </a:r>
+          </a:p>
+        </p:txBody>
+      </p:sp>
+      <p:sp>
+        <p:nvSpPr>
+          <p:cNvPr id="6" name="TextBox 5"/>
+          <p:cNvSpPr txBox="1"/>
+          <p:nvPr/>
+        </p:nvSpPr>
+        <p:spPr>
+          <a:xfrm>
+            <a:off x="1280160" y="4681728"/>
+            <a:ext cx="9692640" cy="457200"/>
+          </a:xfrm>
+          <a:prstGeom prst="rect">
+            <a:avLst/>
+          </a:prstGeom>
+          <a:noFill/>
+        </p:spPr>
+        <p:txBody>
+          <a:bodyPr wrap="square">
+            <a:spAutoFit/>
+          </a:bodyPr>
+          <a:lstStyle/>
+          <a:p>
+            <a:pPr algn="l" indent="-137160" marL="182880">
+              <a:spcBef>
+                <a:spcPts val="0"/>
+              </a:spcBef>
+              <a:spcAft>
+                <a:spcPts val="400"/>
+              </a:spcAft>
+              <a:buChar char="•"/>
+            </a:pPr>
+            <a:r>
+              <a:rPr sz="1350" b="0" i="0">
+                <a:solidFill>
+                  <a:srgbClr val="333333"/>
+                </a:solidFill>
+                <a:latin typeface="Calibri"/>
+              </a:rPr>
+              <a:t>Hoy consigues visibilidad; la S2 la hace útil con etiquetas y asignación.</a:t>
+            </a:r>
+          </a:p>
+        </p:txBody>
+      </p:sp>
+      <p:sp>
+        <p:nvSpPr>
+          <p:cNvPr id="7" name="TextBox 6"/>
+          <p:cNvSpPr txBox="1"/>
+          <p:nvPr/>
+        </p:nvSpPr>
+        <p:spPr>
+          <a:xfrm>
+            <a:off x="1280160" y="5248656"/>
+            <a:ext cx="9692640" cy="457200"/>
+          </a:xfrm>
+          <a:prstGeom prst="rect">
+            <a:avLst/>
+          </a:prstGeom>
+          <a:noFill/>
+        </p:spPr>
+        <p:txBody>
+          <a:bodyPr wrap="square">
+            <a:spAutoFit/>
+          </a:bodyPr>
+          <a:lstStyle/>
+          <a:p>
+            <a:pPr algn="l" indent="-137160" marL="182880">
+              <a:spcBef>
+                <a:spcPts val="0"/>
+              </a:spcBef>
+              <a:spcAft>
+                <a:spcPts val="400"/>
+              </a:spcAft>
+              <a:buChar char="•"/>
+            </a:pPr>
+            <a:r>
+              <a:rPr sz="1350" b="0" i="0">
+                <a:solidFill>
+                  <a:srgbClr val="333333"/>
+                </a:solidFill>
+                <a:latin typeface="Calibri"/>
+              </a:rPr>
+              <a:t>Sin este cimiento, presupuestar (S3) y optimizar (S4) son adivinar.</a:t>
+            </a:r>
+          </a:p>
+        </p:txBody>
+      </p:sp>
+      <p:sp>
+        <p:nvSpPr>
+          <p:cNvPr id="8" name="TextBox 7"/>
+          <p:cNvSpPr txBox="1"/>
+          <p:nvPr/>
+        </p:nvSpPr>
+        <p:spPr>
+          <a:xfrm>
+            <a:off x="502920" y="6473952"/>
+            <a:ext cx="10972800" cy="320040"/>
+          </a:xfrm>
+          <a:prstGeom prst="rect">
+            <a:avLst/>
+          </a:prstGeom>
+          <a:noFill/>
+        </p:spPr>
+        <p:txBody>
+          <a:bodyPr wrap="square">
+            <a:spAutoFit/>
+          </a:bodyPr>
+          <a:lstStyle/>
+          <a:p>
+            <a:pPr algn="l">
+              <a:spcBef>
+                <a:spcPts val="0"/>
+              </a:spcBef>
+              <a:spcAft>
+                <a:spcPts val="400"/>
+              </a:spcAft>
+            </a:pPr>
+            <a:r>
+              <a:rPr sz="1000" b="1" i="0">
+                <a:solidFill>
+                  <a:srgbClr val="008542"/>
+                </a:solidFill>
+                <a:latin typeface="Calibri"/>
+              </a:rPr>
+              <a:t>ean  ·  educación continua   |   88-EAN · FinOps y Optimización de Costos Cloud · Sesión 1</a:t>
+            </a:r>
+          </a:p>
+        </p:txBody>
+      </p:sp>
+    </p:spTree>
+  </p:cSld>
+  <p:clrMapOvr>
+    <a:masterClrMapping/>
+  </p:clrMapOvr>
+</p:sld>
+</file>
+
+<file path=ppt/slides/slide16.xml><?xml version="1.0" encoding="utf-8"?>
+<p:sld xmlns:a="http://schemas.openxmlformats.org/drawingml/2006/main" xmlns:p="http://schemas.openxmlformats.org/presentationml/2006/main" xmlns:r="http://schemas.openxmlformats.org/officeDocument/2006/relationships">
+  <p:cSld>
+    <p:spTree>
+      <p:nvGrpSpPr>
+        <p:cNvPr id="1" name=""/>
+        <p:cNvGrpSpPr/>
+        <p:nvPr/>
+      </p:nvGrpSpPr>
+      <p:grpSpPr/>
+      <p:sp>
+        <p:nvSpPr>
+          <p:cNvPr id="2" name="TextBox 1"/>
+          <p:cNvSpPr txBox="1"/>
+          <p:nvPr/>
+        </p:nvSpPr>
+        <p:spPr>
+          <a:xfrm>
+            <a:off x="502920" y="292608"/>
+            <a:ext cx="11155680" cy="685800"/>
+          </a:xfrm>
+          <a:prstGeom prst="rect">
+            <a:avLst/>
+          </a:prstGeom>
+          <a:noFill/>
+        </p:spPr>
+        <p:txBody>
+          <a:bodyPr wrap="square">
+            <a:spAutoFit/>
+          </a:bodyPr>
+          <a:lstStyle/>
+          <a:p>
+            <a:pPr algn="l">
+              <a:spcBef>
+                <a:spcPts val="0"/>
+              </a:spcBef>
+              <a:spcAft>
+                <a:spcPts val="400"/>
+              </a:spcAft>
+            </a:pPr>
+            <a:r>
+              <a:rPr sz="2900" b="1" i="0">
+                <a:solidFill>
+                  <a:srgbClr val="1A1A1A"/>
+                </a:solidFill>
+                <a:latin typeface="Calibri"/>
+              </a:rPr>
               <a:t>Laboratorio de hoy</a:t>
             </a:r>
           </a:p>
@@ -5901,7 +9042,7 @@
 </p:sld>
 </file>
 
-<file path=ppt/slides/slide14.xml><?xml version="1.0" encoding="utf-8"?>
+<file path=ppt/slides/slide17.xml><?xml version="1.0" encoding="utf-8"?>
 <p:sld xmlns:a="http://schemas.openxmlformats.org/drawingml/2006/main" xmlns:p="http://schemas.openxmlformats.org/presentationml/2006/main" xmlns:r="http://schemas.openxmlformats.org/officeDocument/2006/relationships">
   <p:cSld>
     <p:spTree>

</xml_diff>